<commit_message>
refactor(sales-and-field-enablement): structure into battlecards/ and one-pagers/ subfolders
</commit_message>
<xml_diff>
--- a/eu-policy-company-thesis.pptx
+++ b/eu-policy-company-thesis.pptx
@@ -4,9 +4,6 @@
   <p:sldMasterIdLst>
     <p:sldMasterId id="2147483648" r:id="rId1"/>
   </p:sldMasterIdLst>
-  <p:notesMasterIdLst>
-    <p:notesMasterId r:id="rId10"/>
-  </p:notesMasterIdLst>
   <p:sldIdLst>
     <p:sldId id="256" r:id="rId2"/>
     <p:sldId id="257" r:id="rId3"/>
@@ -17,6 +14,9 @@
     <p:sldId id="262" r:id="rId8"/>
     <p:sldId id="263" r:id="rId9"/>
   </p:sldIdLst>
+  <p:notesMasterIdLst>
+    <p:notesMasterId r:id="rId10"/>
+  </p:notesMasterIdLst>
   <p:sldSz cx="12192000" cy="6858000"/>
   <p:notesSz cx="6858000" cy="12192000"/>
   <p:defaultTextStyle>
@@ -111,11 +111,6 @@
       </a:defRPr>
     </a:lvl9pPr>
   </p:defaultTextStyle>
-  <p:extLst>
-    <p:ext uri="{EFAFB233-063F-42B5-8137-9DF3F51BA10A}">
-      <p15:sldGuideLst xmlns:p15="http://schemas.microsoft.com/office/powerpoint/2012/main"/>
-    </p:ext>
-  </p:extLst>
 </p:presentation>
 </file>
 
@@ -141,10 +136,234 @@
           <a:chExt cx="0" cy="0"/>
         </a:xfrm>
       </p:grpSpPr>
+      <p:sp>
+        <p:nvSpPr>
+          <p:cNvPr id="2" name="Header Placeholder 1"/>
+          <p:cNvSpPr>
+            <a:spLocks noGrp="1"/>
+          </p:cNvSpPr>
+          <p:nvPr>
+            <p:ph type="hdr" sz="quarter"/>
+          </p:nvPr>
+        </p:nvSpPr>
+        <p:spPr>
+          <a:xfrm>
+            <a:off x="0" y="0"/>
+            <a:ext cx="2971800" cy="458788"/>
+          </a:xfrm>
+          <a:prstGeom prst="rect">
+            <a:avLst/>
+          </a:prstGeom>
+        </p:spPr>
+        <p:txBody>
+          <a:bodyPr vert="horz" lIns="91440" tIns="45720" rIns="91440" bIns="45720" rtlCol="0"/>
+          <a:lstStyle>
+            <a:lvl1pPr algn="l">
+              <a:defRPr sz="1200"/>
+            </a:lvl1pPr>
+          </a:lstStyle>
+          <a:p>
+            <a:endParaRPr lang="en-US"/>
+          </a:p>
+        </p:txBody>
+      </p:sp>
+      <p:sp>
+        <p:nvSpPr>
+          <p:cNvPr id="3" name="Date Placeholder 2"/>
+          <p:cNvSpPr>
+            <a:spLocks noGrp="1"/>
+          </p:cNvSpPr>
+          <p:nvPr>
+            <p:ph type="dt" idx="1"/>
+          </p:nvPr>
+        </p:nvSpPr>
+        <p:spPr>
+          <a:xfrm>
+            <a:off x="3884613" y="0"/>
+            <a:ext cx="2971800" cy="458788"/>
+          </a:xfrm>
+          <a:prstGeom prst="rect">
+            <a:avLst/>
+          </a:prstGeom>
+        </p:spPr>
+        <p:txBody>
+          <a:bodyPr vert="horz" lIns="91440" tIns="45720" rIns="91440" bIns="45720" rtlCol="0"/>
+          <a:lstStyle>
+            <a:lvl1pPr algn="r">
+              <a:defRPr sz="1200"/>
+            </a:lvl1pPr>
+          </a:lstStyle>
+          <a:p>
+            <a:fld id="{5282F153-3F37-0F45-9E97-73ACFA13230C}" type="datetimeFigureOut">
+              <a:rPr lang="en-US"/>
+              <a:t>7/23/19</a:t>
+            </a:fld>
+            <a:endParaRPr lang="en-US"/>
+          </a:p>
+        </p:txBody>
+      </p:sp>
+      <p:sp>
+        <p:nvSpPr>
+          <p:cNvPr id="4" name="Slide Image Placeholder 3"/>
+          <p:cNvSpPr>
+            <a:spLocks noGrp="1" noRot="1" noChangeAspect="1"/>
+          </p:cNvSpPr>
+          <p:nvPr>
+            <p:ph type="sldImg" idx="2"/>
+          </p:nvPr>
+        </p:nvSpPr>
+        <p:spPr>
+          <a:xfrm>
+            <a:off x="685800" y="1143000"/>
+            <a:ext cx="5486400" cy="3086100"/>
+          </a:xfrm>
+          <a:prstGeom prst="rect">
+            <a:avLst/>
+          </a:prstGeom>
+          <a:noFill/>
+          <a:ln w="12700">
+            <a:solidFill>
+              <a:prstClr val="black"/>
+            </a:solidFill>
+          </a:ln>
+        </p:spPr>
+        <p:txBody>
+          <a:bodyPr vert="horz" lIns="91440" tIns="45720" rIns="91440" bIns="45720" rtlCol="0" anchor="ctr"/>
+          <a:lstStyle/>
+          <a:p>
+            <a:endParaRPr lang="en-US"/>
+          </a:p>
+        </p:txBody>
+      </p:sp>
+      <p:sp>
+        <p:nvSpPr>
+          <p:cNvPr id="5" name="Notes Placeholder 4"/>
+          <p:cNvSpPr>
+            <a:spLocks noGrp="1"/>
+          </p:cNvSpPr>
+          <p:nvPr>
+            <p:ph type="body" sz="quarter" idx="3"/>
+          </p:nvPr>
+        </p:nvSpPr>
+        <p:spPr>
+          <a:xfrm>
+            <a:off x="685800" y="4400550"/>
+            <a:ext cx="5486400" cy="3600450"/>
+          </a:xfrm>
+          <a:prstGeom prst="rect">
+            <a:avLst/>
+          </a:prstGeom>
+        </p:spPr>
+        <p:txBody>
+          <a:bodyPr vert="horz" lIns="91440" tIns="45720" rIns="91440" bIns="45720" rtlCol="0"/>
+          <a:lstStyle/>
+          <a:p>
+            <a:pPr lvl="0"/>
+            <a:r>
+              <a:rPr lang="en-US"/>
+              <a:t>Click to edit Master text styles</a:t>
+            </a:r>
+          </a:p>
+          <a:p>
+            <a:pPr lvl="1"/>
+            <a:r>
+              <a:rPr lang="en-US"/>
+              <a:t>Second level</a:t>
+            </a:r>
+          </a:p>
+          <a:p>
+            <a:pPr lvl="2"/>
+            <a:r>
+              <a:rPr lang="en-US"/>
+              <a:t>Third level</a:t>
+            </a:r>
+          </a:p>
+          <a:p>
+            <a:pPr lvl="3"/>
+            <a:r>
+              <a:rPr lang="en-US"/>
+              <a:t>Fourth level</a:t>
+            </a:r>
+          </a:p>
+          <a:p>
+            <a:pPr lvl="4"/>
+            <a:r>
+              <a:rPr lang="en-US"/>
+              <a:t>Fifth level</a:t>
+            </a:r>
+          </a:p>
+        </p:txBody>
+      </p:sp>
+      <p:sp>
+        <p:nvSpPr>
+          <p:cNvPr id="6" name="Footer Placeholder 5"/>
+          <p:cNvSpPr>
+            <a:spLocks noGrp="1"/>
+          </p:cNvSpPr>
+          <p:nvPr>
+            <p:ph type="ftr" sz="quarter" idx="4"/>
+          </p:nvPr>
+        </p:nvSpPr>
+        <p:spPr>
+          <a:xfrm>
+            <a:off x="0" y="8685213"/>
+            <a:ext cx="2971800" cy="458787"/>
+          </a:xfrm>
+          <a:prstGeom prst="rect">
+            <a:avLst/>
+          </a:prstGeom>
+        </p:spPr>
+        <p:txBody>
+          <a:bodyPr vert="horz" lIns="91440" tIns="45720" rIns="91440" bIns="45720" rtlCol="0" anchor="b"/>
+          <a:lstStyle>
+            <a:lvl1pPr algn="l">
+              <a:defRPr sz="1200"/>
+            </a:lvl1pPr>
+          </a:lstStyle>
+          <a:p>
+            <a:endParaRPr lang="en-US"/>
+          </a:p>
+        </p:txBody>
+      </p:sp>
+      <p:sp>
+        <p:nvSpPr>
+          <p:cNvPr id="7" name="Slide Number Placeholder 6"/>
+          <p:cNvSpPr>
+            <a:spLocks noGrp="1"/>
+          </p:cNvSpPr>
+          <p:nvPr>
+            <p:ph type="sldNum" sz="quarter" idx="5"/>
+          </p:nvPr>
+        </p:nvSpPr>
+        <p:spPr>
+          <a:xfrm>
+            <a:off x="3884613" y="8685213"/>
+            <a:ext cx="2971800" cy="458787"/>
+          </a:xfrm>
+          <a:prstGeom prst="rect">
+            <a:avLst/>
+          </a:prstGeom>
+        </p:spPr>
+        <p:txBody>
+          <a:bodyPr vert="horz" lIns="91440" tIns="45720" rIns="91440" bIns="45720" rtlCol="0" anchor="b"/>
+          <a:lstStyle>
+            <a:lvl1pPr algn="r">
+              <a:defRPr sz="1200"/>
+            </a:lvl1pPr>
+          </a:lstStyle>
+          <a:p>
+            <a:fld id="{CE5E9CC1-C706-0F49-92D6-E571CC5EEA8F}" type="slidenum">
+              <a:rPr lang="en-US"/>
+              <a:t>‹#›</a:t>
+            </a:fld>
+            <a:endParaRPr lang="en-US"/>
+          </a:p>
+        </p:txBody>
+      </p:sp>
     </p:spTree>
     <p:extLst>
       <p:ext uri="{BB962C8B-B14F-4D97-AF65-F5344CB8AC3E}">
-        <p14:creationId xmlns:p14="http://schemas.microsoft.com/office/powerpoint/2010/main" val="1640890581"/>
+        <p14:creationId xmlns:p14="http://schemas.microsoft.com/office/powerpoint/2010/main" val="1024086991"/>
       </p:ext>
     </p:extLst>
   </p:cSld>
@@ -292,6 +511,7 @@
               <a:rPr lang="en-US" dirty="0"/>
               <a:t>One thesis in two layers: the company strategy explains why Mistral can win the model layer; the policy agenda explains how that win compounds.</a:t>
             </a:r>
+            <a:endParaRPr lang="en-US" dirty="0"/>
           </a:p>
         </p:txBody>
       </p:sp>
@@ -379,6 +599,7 @@
               <a:rPr lang="en-US" dirty="0"/>
               <a:t>The arc is single and linear: control the model layer, feed the loop with adoption, and let the European stack make the position defensible.</a:t>
             </a:r>
+            <a:endParaRPr lang="en-US" dirty="0"/>
           </a:p>
         </p:txBody>
       </p:sp>
@@ -466,6 +687,7 @@
               <a:rPr lang="en-US" dirty="0"/>
               <a:t>Frame the market size first, then the constraints. The constraints make an open, controllable alternative commercially valuable rather than ideological.</a:t>
             </a:r>
+            <a:endParaRPr lang="en-US" dirty="0"/>
           </a:p>
         </p:txBody>
       </p:sp>
@@ -553,6 +775,7 @@
               <a:rPr lang="en-US" dirty="0"/>
               <a:t>The funnel is the defensible part: enterprise counts and sector filters are verifiable, contract values are anchored to comparable enterprise software and infrastructure deals. Share assumption is the one number open to challenge, so lead with it rather than bury it. Note that the bottoms-up total independently lands on the same figure as the top-down forecast, which is the point of the slide.</a:t>
             </a:r>
+            <a:endParaRPr lang="en-US" dirty="0"/>
           </a:p>
         </p:txBody>
       </p:sp>
@@ -640,6 +863,7 @@
               <a:rPr lang="en-US" dirty="0"/>
               <a:t>Land the last line hard. The positioning is deliberate asymmetry, not open-source advocacy.</a:t>
             </a:r>
+            <a:endParaRPr lang="en-US" dirty="0"/>
           </a:p>
         </p:txBody>
       </p:sp>
@@ -727,6 +951,7 @@
               <a:rPr lang="en-US" dirty="0"/>
               <a:t>The loop is the bridge: it converts the company position into a policy agenda without changing the subject.</a:t>
             </a:r>
+            <a:endParaRPr lang="en-US" dirty="0"/>
           </a:p>
         </p:txBody>
       </p:sp>
@@ -814,6 +1039,7 @@
               <a:rPr lang="en-US" dirty="0"/>
               <a:t>Each lever maps to a friction point in the loop: talent and compute feed supply, market and demand levers pull adoption through.</a:t>
             </a:r>
+            <a:endParaRPr lang="en-US" dirty="0"/>
           </a:p>
         </p:txBody>
       </p:sp>
@@ -901,6 +1127,7 @@
               <a:rPr lang="en-US" dirty="0"/>
               <a:t>Close on the single sentence. Everything before it exists to make that sentence credible.</a:t>
             </a:r>
+            <a:endParaRPr lang="en-US" dirty="0"/>
           </a:p>
         </p:txBody>
       </p:sp>
@@ -973,11 +1200,6 @@
 <file path=ppt/slideMasters/slideMaster1.xml><?xml version="1.0" encoding="utf-8"?>
 <p:sldMaster xmlns:a="http://schemas.openxmlformats.org/drawingml/2006/main" xmlns:r="http://schemas.openxmlformats.org/officeDocument/2006/relationships" xmlns:p="http://schemas.openxmlformats.org/presentationml/2006/main">
   <p:cSld>
-    <p:bg>
-      <p:bgRef idx="1001">
-        <a:schemeClr val="bg1"/>
-      </p:bgRef>
-    </p:bg>
     <p:spTree>
       <p:nvGrpSpPr>
         <p:cNvPr id="1" name=""/>
@@ -1260,7 +1482,6 @@
         <a:solidFill>
           <a:srgbClr val="003399"/>
         </a:solidFill>
-        <a:effectLst/>
       </p:bgPr>
     </p:bg>
     <p:spTree>
@@ -1301,13 +1522,6 @@
             <a:prstDash val="solid"/>
           </a:ln>
         </p:spPr>
-        <p:txBody>
-          <a:bodyPr/>
-          <a:lstStyle/>
-          <a:p>
-            <a:endParaRPr lang="en-US"/>
-          </a:p>
-        </p:txBody>
       </p:sp>
       <p:sp>
         <p:nvSpPr>
@@ -1333,13 +1547,6 @@
             <a:prstDash val="solid"/>
           </a:ln>
         </p:spPr>
-        <p:txBody>
-          <a:bodyPr/>
-          <a:lstStyle/>
-          <a:p>
-            <a:endParaRPr lang="en-US"/>
-          </a:p>
-        </p:txBody>
       </p:sp>
       <p:sp>
         <p:nvSpPr>
@@ -1365,13 +1572,6 @@
             <a:prstDash val="solid"/>
           </a:ln>
         </p:spPr>
-        <p:txBody>
-          <a:bodyPr/>
-          <a:lstStyle/>
-          <a:p>
-            <a:endParaRPr lang="en-US"/>
-          </a:p>
-        </p:txBody>
       </p:sp>
       <p:sp>
         <p:nvSpPr>
@@ -1397,13 +1597,6 @@
             <a:prstDash val="solid"/>
           </a:ln>
         </p:spPr>
-        <p:txBody>
-          <a:bodyPr/>
-          <a:lstStyle/>
-          <a:p>
-            <a:endParaRPr lang="en-US"/>
-          </a:p>
-        </p:txBody>
       </p:sp>
       <p:sp>
         <p:nvSpPr>
@@ -1429,13 +1622,6 @@
             <a:prstDash val="solid"/>
           </a:ln>
         </p:spPr>
-        <p:txBody>
-          <a:bodyPr/>
-          <a:lstStyle/>
-          <a:p>
-            <a:endParaRPr lang="en-US"/>
-          </a:p>
-        </p:txBody>
       </p:sp>
       <p:sp>
         <p:nvSpPr>
@@ -1461,13 +1647,6 @@
             <a:prstDash val="solid"/>
           </a:ln>
         </p:spPr>
-        <p:txBody>
-          <a:bodyPr/>
-          <a:lstStyle/>
-          <a:p>
-            <a:endParaRPr lang="en-US"/>
-          </a:p>
-        </p:txBody>
       </p:sp>
       <p:sp>
         <p:nvSpPr>
@@ -1493,13 +1672,6 @@
             <a:prstDash val="solid"/>
           </a:ln>
         </p:spPr>
-        <p:txBody>
-          <a:bodyPr/>
-          <a:lstStyle/>
-          <a:p>
-            <a:endParaRPr lang="en-US"/>
-          </a:p>
-        </p:txBody>
       </p:sp>
       <p:sp>
         <p:nvSpPr>
@@ -1525,13 +1697,6 @@
             <a:prstDash val="solid"/>
           </a:ln>
         </p:spPr>
-        <p:txBody>
-          <a:bodyPr/>
-          <a:lstStyle/>
-          <a:p>
-            <a:endParaRPr lang="en-US"/>
-          </a:p>
-        </p:txBody>
       </p:sp>
       <p:sp>
         <p:nvSpPr>
@@ -1557,13 +1722,6 @@
             <a:prstDash val="solid"/>
           </a:ln>
         </p:spPr>
-        <p:txBody>
-          <a:bodyPr/>
-          <a:lstStyle/>
-          <a:p>
-            <a:endParaRPr lang="en-US"/>
-          </a:p>
-        </p:txBody>
       </p:sp>
       <p:sp>
         <p:nvSpPr>
@@ -1589,13 +1747,6 @@
             <a:prstDash val="solid"/>
           </a:ln>
         </p:spPr>
-        <p:txBody>
-          <a:bodyPr/>
-          <a:lstStyle/>
-          <a:p>
-            <a:endParaRPr lang="en-US"/>
-          </a:p>
-        </p:txBody>
       </p:sp>
       <p:sp>
         <p:nvSpPr>
@@ -1621,13 +1772,6 @@
             <a:prstDash val="solid"/>
           </a:ln>
         </p:spPr>
-        <p:txBody>
-          <a:bodyPr/>
-          <a:lstStyle/>
-          <a:p>
-            <a:endParaRPr lang="en-US"/>
-          </a:p>
-        </p:txBody>
       </p:sp>
       <p:sp>
         <p:nvSpPr>
@@ -1653,24 +1797,17 @@
             <a:prstDash val="solid"/>
           </a:ln>
         </p:spPr>
-        <p:txBody>
-          <a:bodyPr/>
-          <a:lstStyle/>
-          <a:p>
-            <a:endParaRPr lang="en-US"/>
-          </a:p>
-        </p:txBody>
       </p:sp>
       <p:pic>
         <p:nvPicPr>
-          <p:cNvPr id="14" name="Image 0" descr="preencoded.png"/>
+          <p:cNvPr id="14" name="Image 0" descr="preencoded.png">    </p:cNvPr>
           <p:cNvPicPr>
             <a:picLocks noChangeAspect="1"/>
           </p:cNvPicPr>
           <p:nvPr/>
         </p:nvPicPr>
         <p:blipFill>
-          <a:blip r:embed="rId3"/>
+          <a:blip r:embed="rId1"/>
           <a:stretch>
             <a:fillRect/>
           </a:stretch>
@@ -1706,11 +1843,11 @@
           <a:bodyPr wrap="square" lIns="0" tIns="0" rIns="0" bIns="0" rtlCol="0" anchor="ctr"/>
           <a:lstStyle/>
           <a:p>
-            <a:pPr marL="0" indent="0">
-              <a:buNone/>
-            </a:pPr>
-            <a:r>
-              <a:rPr lang="en-US" sz="1200" b="1" kern="0" spc="300" dirty="0">
+            <a:pPr indent="0" marL="0">
+              <a:buNone/>
+            </a:pPr>
+            <a:r>
+              <a:rPr lang="en-US" sz="1200" b="1" spc="300" kern="0" dirty="0">
                 <a:solidFill>
                   <a:srgbClr val="FFCC00"/>
                 </a:solidFill>
@@ -1745,7 +1882,7 @@
           <a:bodyPr wrap="square" lIns="0" tIns="0" rIns="0" bIns="0" rtlCol="0" anchor="ctr"/>
           <a:lstStyle/>
           <a:p>
-            <a:pPr marL="0" indent="0">
+            <a:pPr indent="0" marL="0">
               <a:lnSpc>
                 <a:spcPts val="5200"/>
               </a:lnSpc>
@@ -1765,7 +1902,7 @@
             <a:endParaRPr lang="en-US" sz="4600" dirty="0"/>
           </a:p>
           <a:p>
-            <a:pPr marL="0" indent="0">
+            <a:pPr indent="0" marL="0">
               <a:lnSpc>
                 <a:spcPts val="5200"/>
               </a:lnSpc>
@@ -1807,7 +1944,7 @@
           <a:bodyPr wrap="square" lIns="0" tIns="0" rIns="0" bIns="0" rtlCol="0" anchor="ctr"/>
           <a:lstStyle/>
           <a:p>
-            <a:pPr marL="0" indent="0">
+            <a:pPr indent="0" marL="0">
               <a:lnSpc>
                 <a:spcPts val="2400"/>
               </a:lnSpc>
@@ -1849,7 +1986,7 @@
           <a:bodyPr wrap="square" lIns="0" tIns="0" rIns="0" bIns="0" rtlCol="0" anchor="ctr"/>
           <a:lstStyle/>
           <a:p>
-            <a:pPr marL="0" indent="0">
+            <a:pPr indent="0" marL="0">
               <a:buNone/>
             </a:pPr>
             <a:r>
@@ -1888,7 +2025,7 @@
           <a:bodyPr wrap="square" lIns="0" tIns="0" rIns="0" bIns="0" rtlCol="0" anchor="ctr"/>
           <a:lstStyle/>
           <a:p>
-            <a:pPr marL="0" indent="0">
+            <a:pPr indent="0" marL="0">
               <a:buNone/>
             </a:pPr>
             <a:r>
@@ -1922,7 +2059,6 @@
         <a:solidFill>
           <a:srgbClr val="FFFFFF"/>
         </a:solidFill>
-        <a:effectLst/>
       </p:bgPr>
     </p:bg>
     <p:spTree>
@@ -1963,13 +2099,6 @@
             <a:prstDash val="solid"/>
           </a:ln>
         </p:spPr>
-        <p:txBody>
-          <a:bodyPr/>
-          <a:lstStyle/>
-          <a:p>
-            <a:endParaRPr lang="en-US"/>
-          </a:p>
-        </p:txBody>
       </p:sp>
       <p:sp>
         <p:nvSpPr>
@@ -1992,7 +2121,7 @@
           <a:bodyPr wrap="square" lIns="0" tIns="0" rIns="0" bIns="0" rtlCol="0" anchor="ctr"/>
           <a:lstStyle/>
           <a:p>
-            <a:pPr marL="0" indent="0" algn="ctr">
+            <a:pPr algn="ctr" indent="0" marL="0">
               <a:buNone/>
             </a:pPr>
             <a:r>
@@ -2031,11 +2160,11 @@
           <a:bodyPr wrap="square" lIns="0" tIns="0" rIns="0" bIns="0" rtlCol="0" anchor="ctr"/>
           <a:lstStyle/>
           <a:p>
-            <a:pPr marL="0" indent="0">
-              <a:buNone/>
-            </a:pPr>
-            <a:r>
-              <a:rPr lang="en-US" sz="1100" b="1" kern="0" spc="200" dirty="0">
+            <a:pPr indent="0" marL="0">
+              <a:buNone/>
+            </a:pPr>
+            <a:r>
+              <a:rPr lang="en-US" sz="1100" b="1" spc="200" kern="0" dirty="0">
                 <a:solidFill>
                   <a:srgbClr val="003399"/>
                 </a:solidFill>
@@ -2070,7 +2199,7 @@
           <a:bodyPr wrap="square" lIns="0" tIns="0" rIns="0" bIns="0" rtlCol="0" anchor="ctr"/>
           <a:lstStyle/>
           <a:p>
-            <a:pPr marL="0" indent="0">
+            <a:pPr indent="0" marL="0">
               <a:buNone/>
             </a:pPr>
             <a:r>
@@ -2109,7 +2238,7 @@
           <a:bodyPr wrap="square" lIns="0" tIns="0" rIns="0" bIns="0" rtlCol="0" anchor="ctr"/>
           <a:lstStyle/>
           <a:p>
-            <a:pPr marL="0" indent="0">
+            <a:pPr indent="0" marL="0">
               <a:buNone/>
             </a:pPr>
             <a:r>
@@ -2153,13 +2282,6 @@
             <a:prstDash val="solid"/>
           </a:ln>
         </p:spPr>
-        <p:txBody>
-          <a:bodyPr/>
-          <a:lstStyle/>
-          <a:p>
-            <a:endParaRPr lang="en-US"/>
-          </a:p>
-        </p:txBody>
       </p:sp>
       <p:sp>
         <p:nvSpPr>
@@ -2185,13 +2307,6 @@
             <a:prstDash val="solid"/>
           </a:ln>
         </p:spPr>
-        <p:txBody>
-          <a:bodyPr/>
-          <a:lstStyle/>
-          <a:p>
-            <a:endParaRPr lang="en-US"/>
-          </a:p>
-        </p:txBody>
       </p:sp>
       <p:sp>
         <p:nvSpPr>
@@ -2214,7 +2329,7 @@
           <a:bodyPr wrap="square" lIns="0" tIns="0" rIns="0" bIns="0" rtlCol="0" anchor="ctr"/>
           <a:lstStyle/>
           <a:p>
-            <a:pPr marL="0" indent="0" algn="ctr">
+            <a:pPr algn="ctr" indent="0" marL="0">
               <a:buNone/>
             </a:pPr>
             <a:r>
@@ -2253,7 +2368,7 @@
           <a:bodyPr wrap="square" lIns="0" tIns="0" rIns="0" bIns="0" rtlCol="0" anchor="ctr"/>
           <a:lstStyle/>
           <a:p>
-            <a:pPr marL="0" indent="0">
+            <a:pPr indent="0" marL="0">
               <a:buNone/>
             </a:pPr>
             <a:r>
@@ -2292,7 +2407,7 @@
           <a:bodyPr wrap="square" lIns="0" tIns="0" rIns="0" bIns="0" rtlCol="0" anchor="ctr"/>
           <a:lstStyle/>
           <a:p>
-            <a:pPr marL="0" indent="0">
+            <a:pPr indent="0" marL="0">
               <a:lnSpc>
                 <a:spcPts val="2000"/>
               </a:lnSpc>
@@ -2339,13 +2454,6 @@
             <a:prstDash val="solid"/>
           </a:ln>
         </p:spPr>
-        <p:txBody>
-          <a:bodyPr/>
-          <a:lstStyle/>
-          <a:p>
-            <a:endParaRPr lang="en-US"/>
-          </a:p>
-        </p:txBody>
       </p:sp>
       <p:sp>
         <p:nvSpPr>
@@ -2371,13 +2479,6 @@
             <a:prstDash val="solid"/>
           </a:ln>
         </p:spPr>
-        <p:txBody>
-          <a:bodyPr/>
-          <a:lstStyle/>
-          <a:p>
-            <a:endParaRPr lang="en-US"/>
-          </a:p>
-        </p:txBody>
       </p:sp>
       <p:sp>
         <p:nvSpPr>
@@ -2400,7 +2501,7 @@
           <a:bodyPr wrap="square" lIns="0" tIns="0" rIns="0" bIns="0" rtlCol="0" anchor="ctr"/>
           <a:lstStyle/>
           <a:p>
-            <a:pPr marL="0" indent="0" algn="ctr">
+            <a:pPr algn="ctr" indent="0" marL="0">
               <a:buNone/>
             </a:pPr>
             <a:r>
@@ -2439,7 +2540,7 @@
           <a:bodyPr wrap="square" lIns="0" tIns="0" rIns="0" bIns="0" rtlCol="0" anchor="ctr"/>
           <a:lstStyle/>
           <a:p>
-            <a:pPr marL="0" indent="0">
+            <a:pPr indent="0" marL="0">
               <a:buNone/>
             </a:pPr>
             <a:r>
@@ -2478,7 +2579,7 @@
           <a:bodyPr wrap="square" lIns="0" tIns="0" rIns="0" bIns="0" rtlCol="0" anchor="ctr"/>
           <a:lstStyle/>
           <a:p>
-            <a:pPr marL="0" indent="0">
+            <a:pPr indent="0" marL="0">
               <a:lnSpc>
                 <a:spcPts val="2000"/>
               </a:lnSpc>
@@ -2525,13 +2626,6 @@
             <a:prstDash val="solid"/>
           </a:ln>
         </p:spPr>
-        <p:txBody>
-          <a:bodyPr/>
-          <a:lstStyle/>
-          <a:p>
-            <a:endParaRPr lang="en-US"/>
-          </a:p>
-        </p:txBody>
       </p:sp>
       <p:sp>
         <p:nvSpPr>
@@ -2557,13 +2651,6 @@
             <a:prstDash val="solid"/>
           </a:ln>
         </p:spPr>
-        <p:txBody>
-          <a:bodyPr/>
-          <a:lstStyle/>
-          <a:p>
-            <a:endParaRPr lang="en-US"/>
-          </a:p>
-        </p:txBody>
       </p:sp>
       <p:sp>
         <p:nvSpPr>
@@ -2586,7 +2673,7 @@
           <a:bodyPr wrap="square" lIns="0" tIns="0" rIns="0" bIns="0" rtlCol="0" anchor="ctr"/>
           <a:lstStyle/>
           <a:p>
-            <a:pPr marL="0" indent="0" algn="ctr">
+            <a:pPr algn="ctr" indent="0" marL="0">
               <a:buNone/>
             </a:pPr>
             <a:r>
@@ -2625,7 +2712,7 @@
           <a:bodyPr wrap="square" lIns="0" tIns="0" rIns="0" bIns="0" rtlCol="0" anchor="ctr"/>
           <a:lstStyle/>
           <a:p>
-            <a:pPr marL="0" indent="0">
+            <a:pPr indent="0" marL="0">
               <a:buNone/>
             </a:pPr>
             <a:r>
@@ -2664,7 +2751,7 @@
           <a:bodyPr wrap="square" lIns="0" tIns="0" rIns="0" bIns="0" rtlCol="0" anchor="ctr"/>
           <a:lstStyle/>
           <a:p>
-            <a:pPr marL="0" indent="0">
+            <a:pPr indent="0" marL="0">
               <a:lnSpc>
                 <a:spcPts val="2000"/>
               </a:lnSpc>
@@ -2706,7 +2793,7 @@
           <a:bodyPr wrap="square" lIns="0" tIns="0" rIns="0" bIns="0" rtlCol="0" anchor="ctr"/>
           <a:lstStyle/>
           <a:p>
-            <a:pPr marL="0" indent="0" algn="ctr">
+            <a:pPr algn="ctr" indent="0" marL="0">
               <a:buNone/>
             </a:pPr>
             <a:r>
@@ -2745,7 +2832,7 @@
           <a:bodyPr wrap="square" lIns="0" tIns="0" rIns="0" bIns="0" rtlCol="0" anchor="ctr"/>
           <a:lstStyle/>
           <a:p>
-            <a:pPr marL="0" indent="0">
+            <a:pPr indent="0" marL="0">
               <a:buNone/>
             </a:pPr>
             <a:r>
@@ -2784,7 +2871,7 @@
           <a:bodyPr wrap="square" lIns="0" tIns="0" rIns="0" bIns="0" rtlCol="0" anchor="ctr"/>
           <a:lstStyle/>
           <a:p>
-            <a:pPr marL="0" indent="0" algn="r">
+            <a:pPr algn="r" indent="0" marL="0">
               <a:buNone/>
             </a:pPr>
             <a:r>
@@ -2818,7 +2905,6 @@
         <a:solidFill>
           <a:srgbClr val="FFFFFF"/>
         </a:solidFill>
-        <a:effectLst/>
       </p:bgPr>
     </p:bg>
     <p:spTree>
@@ -2859,13 +2945,6 @@
             <a:prstDash val="solid"/>
           </a:ln>
         </p:spPr>
-        <p:txBody>
-          <a:bodyPr/>
-          <a:lstStyle/>
-          <a:p>
-            <a:endParaRPr lang="en-US"/>
-          </a:p>
-        </p:txBody>
       </p:sp>
       <p:sp>
         <p:nvSpPr>
@@ -2888,7 +2967,7 @@
           <a:bodyPr wrap="square" lIns="0" tIns="0" rIns="0" bIns="0" rtlCol="0" anchor="ctr"/>
           <a:lstStyle/>
           <a:p>
-            <a:pPr marL="0" indent="0" algn="ctr">
+            <a:pPr algn="ctr" indent="0" marL="0">
               <a:buNone/>
             </a:pPr>
             <a:r>
@@ -2927,11 +3006,11 @@
           <a:bodyPr wrap="square" lIns="0" tIns="0" rIns="0" bIns="0" rtlCol="0" anchor="ctr"/>
           <a:lstStyle/>
           <a:p>
-            <a:pPr marL="0" indent="0">
-              <a:buNone/>
-            </a:pPr>
-            <a:r>
-              <a:rPr lang="en-US" sz="1100" b="1" kern="0" spc="200" dirty="0">
+            <a:pPr indent="0" marL="0">
+              <a:buNone/>
+            </a:pPr>
+            <a:r>
+              <a:rPr lang="en-US" sz="1100" b="1" spc="200" kern="0" dirty="0">
                 <a:solidFill>
                   <a:srgbClr val="003399"/>
                 </a:solidFill>
@@ -2966,7 +3045,7 @@
           <a:bodyPr wrap="square" lIns="0" tIns="0" rIns="0" bIns="0" rtlCol="0" anchor="ctr"/>
           <a:lstStyle/>
           <a:p>
-            <a:pPr marL="0" indent="0">
+            <a:pPr indent="0" marL="0">
               <a:buNone/>
             </a:pPr>
             <a:r>
@@ -3005,7 +3084,7 @@
           <a:bodyPr wrap="square" lIns="0" tIns="0" rIns="0" bIns="0" rtlCol="0" anchor="ctr"/>
           <a:lstStyle/>
           <a:p>
-            <a:pPr marL="0" indent="0">
+            <a:pPr indent="0" marL="0">
               <a:buNone/>
             </a:pPr>
             <a:r>
@@ -3049,13 +3128,6 @@
             <a:prstDash val="solid"/>
           </a:ln>
         </p:spPr>
-        <p:txBody>
-          <a:bodyPr/>
-          <a:lstStyle/>
-          <a:p>
-            <a:endParaRPr lang="en-US"/>
-          </a:p>
-        </p:txBody>
       </p:sp>
       <p:sp>
         <p:nvSpPr>
@@ -3078,7 +3150,7 @@
           <a:bodyPr wrap="square" lIns="0" tIns="0" rIns="0" bIns="0" rtlCol="0" anchor="ctr"/>
           <a:lstStyle/>
           <a:p>
-            <a:pPr marL="0" indent="0">
+            <a:pPr indent="0" marL="0">
               <a:buNone/>
             </a:pPr>
             <a:r>
@@ -3117,7 +3189,7 @@
           <a:bodyPr wrap="square" lIns="0" tIns="0" rIns="0" bIns="0" rtlCol="0" anchor="ctr"/>
           <a:lstStyle/>
           <a:p>
-            <a:pPr marL="0" indent="0">
+            <a:pPr indent="0" marL="0">
               <a:buNone/>
             </a:pPr>
             <a:r>
@@ -3161,13 +3233,6 @@
             <a:prstDash val="solid"/>
           </a:ln>
         </p:spPr>
-        <p:txBody>
-          <a:bodyPr/>
-          <a:lstStyle/>
-          <a:p>
-            <a:endParaRPr lang="en-US"/>
-          </a:p>
-        </p:txBody>
       </p:sp>
       <p:sp>
         <p:nvSpPr>
@@ -3190,7 +3255,7 @@
           <a:bodyPr wrap="square" lIns="0" tIns="0" rIns="0" bIns="0" rtlCol="0" anchor="ctr"/>
           <a:lstStyle/>
           <a:p>
-            <a:pPr marL="0" indent="0">
+            <a:pPr indent="0" marL="0">
               <a:buNone/>
             </a:pPr>
             <a:r>
@@ -3229,7 +3294,7 @@
           <a:bodyPr wrap="square" lIns="0" tIns="0" rIns="0" bIns="0" rtlCol="0" anchor="ctr"/>
           <a:lstStyle/>
           <a:p>
-            <a:pPr marL="0" indent="0">
+            <a:pPr indent="0" marL="0">
               <a:buNone/>
             </a:pPr>
             <a:r>
@@ -3273,13 +3338,6 @@
             <a:prstDash val="solid"/>
           </a:ln>
         </p:spPr>
-        <p:txBody>
-          <a:bodyPr/>
-          <a:lstStyle/>
-          <a:p>
-            <a:endParaRPr lang="en-US"/>
-          </a:p>
-        </p:txBody>
       </p:sp>
       <p:sp>
         <p:nvSpPr>
@@ -3302,7 +3360,7 @@
           <a:bodyPr wrap="square" lIns="0" tIns="0" rIns="0" bIns="0" rtlCol="0" anchor="ctr"/>
           <a:lstStyle/>
           <a:p>
-            <a:pPr marL="0" indent="0">
+            <a:pPr indent="0" marL="0">
               <a:buNone/>
             </a:pPr>
             <a:r>
@@ -3341,7 +3399,7 @@
           <a:bodyPr wrap="square" lIns="0" tIns="0" rIns="0" bIns="0" rtlCol="0" anchor="ctr"/>
           <a:lstStyle/>
           <a:p>
-            <a:pPr marL="0" indent="0">
+            <a:pPr indent="0" marL="0">
               <a:buNone/>
             </a:pPr>
             <a:r>
@@ -3380,11 +3438,11 @@
           <a:bodyPr wrap="square" lIns="0" tIns="0" rIns="0" bIns="0" rtlCol="0" anchor="ctr"/>
           <a:lstStyle/>
           <a:p>
-            <a:pPr marL="0" indent="0">
-              <a:buNone/>
-            </a:pPr>
-            <a:r>
-              <a:rPr lang="en-US" sz="1200" b="1" kern="0" spc="150" dirty="0">
+            <a:pPr indent="0" marL="0">
+              <a:buNone/>
+            </a:pPr>
+            <a:r>
+              <a:rPr lang="en-US" sz="1200" b="1" spc="150" kern="0" dirty="0">
                 <a:solidFill>
                   <a:srgbClr val="003399"/>
                 </a:solidFill>
@@ -3422,13 +3480,6 @@
             <a:prstDash val="solid"/>
           </a:ln>
         </p:spPr>
-        <p:txBody>
-          <a:bodyPr/>
-          <a:lstStyle/>
-          <a:p>
-            <a:endParaRPr lang="en-US"/>
-          </a:p>
-        </p:txBody>
       </p:sp>
       <p:sp>
         <p:nvSpPr>
@@ -3451,7 +3502,7 @@
           <a:bodyPr wrap="square" lIns="0" tIns="0" rIns="0" bIns="0" rtlCol="0" anchor="ctr"/>
           <a:lstStyle/>
           <a:p>
-            <a:pPr marL="0" indent="0">
+            <a:pPr indent="0" marL="0">
               <a:buNone/>
             </a:pPr>
             <a:r>
@@ -3493,13 +3544,6 @@
             <a:prstDash val="solid"/>
           </a:ln>
         </p:spPr>
-        <p:txBody>
-          <a:bodyPr/>
-          <a:lstStyle/>
-          <a:p>
-            <a:endParaRPr lang="en-US"/>
-          </a:p>
-        </p:txBody>
       </p:sp>
       <p:sp>
         <p:nvSpPr>
@@ -3522,7 +3566,7 @@
           <a:bodyPr wrap="square" lIns="0" tIns="0" rIns="0" bIns="0" rtlCol="0" anchor="ctr"/>
           <a:lstStyle/>
           <a:p>
-            <a:pPr marL="0" indent="0">
+            <a:pPr indent="0" marL="0">
               <a:buNone/>
             </a:pPr>
             <a:r>
@@ -3564,13 +3608,6 @@
             <a:prstDash val="solid"/>
           </a:ln>
         </p:spPr>
-        <p:txBody>
-          <a:bodyPr/>
-          <a:lstStyle/>
-          <a:p>
-            <a:endParaRPr lang="en-US"/>
-          </a:p>
-        </p:txBody>
       </p:sp>
       <p:sp>
         <p:nvSpPr>
@@ -3593,7 +3630,7 @@
           <a:bodyPr wrap="square" lIns="0" tIns="0" rIns="0" bIns="0" rtlCol="0" anchor="ctr"/>
           <a:lstStyle/>
           <a:p>
-            <a:pPr marL="0" indent="0">
+            <a:pPr indent="0" marL="0">
               <a:buNone/>
             </a:pPr>
             <a:r>
@@ -3632,7 +3669,7 @@
           <a:bodyPr wrap="square" lIns="0" tIns="0" rIns="0" bIns="0" rtlCol="0" anchor="ctr"/>
           <a:lstStyle/>
           <a:p>
-            <a:pPr marL="0" indent="0">
+            <a:pPr indent="0" marL="0">
               <a:buNone/>
             </a:pPr>
             <a:r>
@@ -3671,7 +3708,7 @@
           <a:bodyPr wrap="square" lIns="0" tIns="0" rIns="0" bIns="0" rtlCol="0" anchor="ctr"/>
           <a:lstStyle/>
           <a:p>
-            <a:pPr marL="0" indent="0" algn="r">
+            <a:pPr algn="r" indent="0" marL="0">
               <a:buNone/>
             </a:pPr>
             <a:r>
@@ -3705,7 +3742,6 @@
         <a:solidFill>
           <a:srgbClr val="FFFFFF"/>
         </a:solidFill>
-        <a:effectLst/>
       </p:bgPr>
     </p:bg>
     <p:spTree>
@@ -3746,13 +3782,6 @@
             <a:prstDash val="solid"/>
           </a:ln>
         </p:spPr>
-        <p:txBody>
-          <a:bodyPr/>
-          <a:lstStyle/>
-          <a:p>
-            <a:endParaRPr lang="en-US"/>
-          </a:p>
-        </p:txBody>
       </p:sp>
       <p:sp>
         <p:nvSpPr>
@@ -3775,7 +3804,7 @@
           <a:bodyPr wrap="square" lIns="0" tIns="0" rIns="0" bIns="0" rtlCol="0" anchor="ctr"/>
           <a:lstStyle/>
           <a:p>
-            <a:pPr marL="0" indent="0" algn="ctr">
+            <a:pPr algn="ctr" indent="0" marL="0">
               <a:buNone/>
             </a:pPr>
             <a:r>
@@ -3814,11 +3843,11 @@
           <a:bodyPr wrap="square" lIns="0" tIns="0" rIns="0" bIns="0" rtlCol="0" anchor="ctr"/>
           <a:lstStyle/>
           <a:p>
-            <a:pPr marL="0" indent="0">
-              <a:buNone/>
-            </a:pPr>
-            <a:r>
-              <a:rPr lang="en-US" sz="1100" b="1" kern="0" spc="200" dirty="0">
+            <a:pPr indent="0" marL="0">
+              <a:buNone/>
+            </a:pPr>
+            <a:r>
+              <a:rPr lang="en-US" sz="1100" b="1" spc="200" kern="0" dirty="0">
                 <a:solidFill>
                   <a:srgbClr val="003399"/>
                 </a:solidFill>
@@ -3853,7 +3882,7 @@
           <a:bodyPr wrap="square" lIns="0" tIns="0" rIns="0" bIns="0" rtlCol="0" anchor="ctr"/>
           <a:lstStyle/>
           <a:p>
-            <a:pPr marL="0" indent="0">
+            <a:pPr indent="0" marL="0">
               <a:buNone/>
             </a:pPr>
             <a:r>
@@ -3892,7 +3921,7 @@
           <a:bodyPr wrap="square" lIns="0" tIns="0" rIns="0" bIns="0" rtlCol="0" anchor="ctr"/>
           <a:lstStyle/>
           <a:p>
-            <a:pPr marL="0" indent="0">
+            <a:pPr indent="0" marL="0">
               <a:buNone/>
             </a:pPr>
             <a:r>
@@ -3936,13 +3965,6 @@
             <a:prstDash val="solid"/>
           </a:ln>
         </p:spPr>
-        <p:txBody>
-          <a:bodyPr/>
-          <a:lstStyle/>
-          <a:p>
-            <a:endParaRPr lang="en-US"/>
-          </a:p>
-        </p:txBody>
       </p:sp>
       <p:sp>
         <p:nvSpPr>
@@ -3965,7 +3987,7 @@
           <a:bodyPr wrap="square" lIns="0" tIns="0" rIns="0" bIns="0" rtlCol="0" anchor="ctr"/>
           <a:lstStyle/>
           <a:p>
-            <a:pPr marL="0" indent="0">
+            <a:pPr indent="0" marL="0">
               <a:buNone/>
             </a:pPr>
             <a:r>
@@ -4004,7 +4026,7 @@
           <a:bodyPr wrap="square" lIns="0" tIns="0" rIns="0" bIns="0" rtlCol="0" anchor="ctr"/>
           <a:lstStyle/>
           <a:p>
-            <a:pPr marL="0" indent="0">
+            <a:pPr indent="0" marL="0">
               <a:lnSpc>
                 <a:spcPts val="1500"/>
               </a:lnSpc>
@@ -4024,7 +4046,7 @@
             <a:endParaRPr lang="en-US" sz="1150" dirty="0"/>
           </a:p>
           <a:p>
-            <a:pPr marL="0" indent="0">
+            <a:pPr indent="0" marL="0">
               <a:lnSpc>
                 <a:spcPts val="1500"/>
               </a:lnSpc>
@@ -4069,13 +4091,6 @@
             <a:prstDash val="solid"/>
           </a:ln>
         </p:spPr>
-        <p:txBody>
-          <a:bodyPr/>
-          <a:lstStyle/>
-          <a:p>
-            <a:endParaRPr lang="en-US"/>
-          </a:p>
-        </p:txBody>
       </p:sp>
       <p:sp>
         <p:nvSpPr>
@@ -4103,13 +4118,6 @@
             <a:prstDash val="solid"/>
           </a:ln>
         </p:spPr>
-        <p:txBody>
-          <a:bodyPr/>
-          <a:lstStyle/>
-          <a:p>
-            <a:endParaRPr lang="en-US"/>
-          </a:p>
-        </p:txBody>
       </p:sp>
       <p:sp>
         <p:nvSpPr>
@@ -4132,7 +4140,7 @@
           <a:bodyPr wrap="square" lIns="0" tIns="0" rIns="0" bIns="0" rtlCol="0" anchor="ctr"/>
           <a:lstStyle/>
           <a:p>
-            <a:pPr marL="0" indent="0">
+            <a:pPr indent="0" marL="0">
               <a:buNone/>
             </a:pPr>
             <a:r>
@@ -4171,7 +4179,7 @@
           <a:bodyPr wrap="square" lIns="0" tIns="0" rIns="0" bIns="0" rtlCol="0" anchor="ctr"/>
           <a:lstStyle/>
           <a:p>
-            <a:pPr marL="0" indent="0">
+            <a:pPr indent="0" marL="0">
               <a:lnSpc>
                 <a:spcPts val="1500"/>
               </a:lnSpc>
@@ -4191,7 +4199,7 @@
             <a:endParaRPr lang="en-US" sz="1150" dirty="0"/>
           </a:p>
           <a:p>
-            <a:pPr marL="0" indent="0">
+            <a:pPr indent="0" marL="0">
               <a:lnSpc>
                 <a:spcPts val="1500"/>
               </a:lnSpc>
@@ -4236,13 +4244,6 @@
             <a:prstDash val="solid"/>
           </a:ln>
         </p:spPr>
-        <p:txBody>
-          <a:bodyPr/>
-          <a:lstStyle/>
-          <a:p>
-            <a:endParaRPr lang="en-US"/>
-          </a:p>
-        </p:txBody>
       </p:sp>
       <p:sp>
         <p:nvSpPr>
@@ -4270,13 +4271,6 @@
             <a:prstDash val="solid"/>
           </a:ln>
         </p:spPr>
-        <p:txBody>
-          <a:bodyPr/>
-          <a:lstStyle/>
-          <a:p>
-            <a:endParaRPr lang="en-US"/>
-          </a:p>
-        </p:txBody>
       </p:sp>
       <p:sp>
         <p:nvSpPr>
@@ -4299,7 +4293,7 @@
           <a:bodyPr wrap="square" lIns="0" tIns="0" rIns="0" bIns="0" rtlCol="0" anchor="ctr"/>
           <a:lstStyle/>
           <a:p>
-            <a:pPr marL="0" indent="0">
+            <a:pPr indent="0" marL="0">
               <a:buNone/>
             </a:pPr>
             <a:r>
@@ -4338,7 +4332,7 @@
           <a:bodyPr wrap="square" lIns="0" tIns="0" rIns="0" bIns="0" rtlCol="0" anchor="ctr"/>
           <a:lstStyle/>
           <a:p>
-            <a:pPr marL="0" indent="0">
+            <a:pPr indent="0" marL="0">
               <a:lnSpc>
                 <a:spcPts val="1500"/>
               </a:lnSpc>
@@ -4358,7 +4352,7 @@
             <a:endParaRPr lang="en-US" sz="1150" dirty="0"/>
           </a:p>
           <a:p>
-            <a:pPr marL="0" indent="0">
+            <a:pPr indent="0" marL="0">
               <a:lnSpc>
                 <a:spcPts val="1500"/>
               </a:lnSpc>
@@ -4403,13 +4397,6 @@
             <a:prstDash val="solid"/>
           </a:ln>
         </p:spPr>
-        <p:txBody>
-          <a:bodyPr/>
-          <a:lstStyle/>
-          <a:p>
-            <a:endParaRPr lang="en-US"/>
-          </a:p>
-        </p:txBody>
       </p:sp>
       <p:sp>
         <p:nvSpPr>
@@ -4437,13 +4424,6 @@
             <a:prstDash val="solid"/>
           </a:ln>
         </p:spPr>
-        <p:txBody>
-          <a:bodyPr/>
-          <a:lstStyle/>
-          <a:p>
-            <a:endParaRPr lang="en-US"/>
-          </a:p>
-        </p:txBody>
       </p:sp>
       <p:sp>
         <p:nvSpPr>
@@ -4466,7 +4446,7 @@
           <a:bodyPr wrap="square" lIns="0" tIns="0" rIns="0" bIns="0" rtlCol="0" anchor="ctr"/>
           <a:lstStyle/>
           <a:p>
-            <a:pPr marL="0" indent="0">
+            <a:pPr indent="0" marL="0">
               <a:buNone/>
             </a:pPr>
             <a:r>
@@ -4505,7 +4485,7 @@
           <a:bodyPr wrap="square" lIns="0" tIns="0" rIns="0" bIns="0" rtlCol="0" anchor="ctr"/>
           <a:lstStyle/>
           <a:p>
-            <a:pPr marL="0" indent="0">
+            <a:pPr indent="0" marL="0">
               <a:lnSpc>
                 <a:spcPts val="1500"/>
               </a:lnSpc>
@@ -4525,7 +4505,7 @@
             <a:endParaRPr lang="en-US" sz="1150" dirty="0"/>
           </a:p>
           <a:p>
-            <a:pPr marL="0" indent="0">
+            <a:pPr indent="0" marL="0">
               <a:lnSpc>
                 <a:spcPts val="1500"/>
               </a:lnSpc>
@@ -4567,11 +4547,11 @@
           <a:bodyPr wrap="square" lIns="0" tIns="0" rIns="0" bIns="0" rtlCol="0" anchor="ctr"/>
           <a:lstStyle/>
           <a:p>
-            <a:pPr marL="0" indent="0">
-              <a:buNone/>
-            </a:pPr>
-            <a:r>
-              <a:rPr lang="en-US" sz="1100" b="1" kern="0" spc="150" dirty="0">
+            <a:pPr indent="0" marL="0">
+              <a:buNone/>
+            </a:pPr>
+            <a:r>
+              <a:rPr lang="en-US" sz="1100" b="1" spc="150" kern="0" dirty="0">
                 <a:solidFill>
                   <a:srgbClr val="003399"/>
                 </a:solidFill>
@@ -4611,13 +4591,6 @@
             <a:prstDash val="solid"/>
           </a:ln>
         </p:spPr>
-        <p:txBody>
-          <a:bodyPr/>
-          <a:lstStyle/>
-          <a:p>
-            <a:endParaRPr lang="en-US"/>
-          </a:p>
-        </p:txBody>
       </p:sp>
       <p:sp>
         <p:nvSpPr>
@@ -4640,7 +4613,7 @@
           <a:bodyPr wrap="square" lIns="0" tIns="0" rIns="0" bIns="0" rtlCol="0" anchor="ctr"/>
           <a:lstStyle/>
           <a:p>
-            <a:pPr marL="0" indent="0">
+            <a:pPr indent="0" marL="0">
               <a:buNone/>
             </a:pPr>
             <a:r>
@@ -4679,7 +4652,7 @@
           <a:bodyPr wrap="square" lIns="0" tIns="0" rIns="0" bIns="0" rtlCol="0" anchor="ctr"/>
           <a:lstStyle/>
           <a:p>
-            <a:pPr marL="0" indent="0">
+            <a:pPr indent="0" marL="0">
               <a:buNone/>
             </a:pPr>
             <a:r>
@@ -4718,7 +4691,7 @@
           <a:bodyPr wrap="square" lIns="0" tIns="0" rIns="0" bIns="0" rtlCol="0" anchor="ctr"/>
           <a:lstStyle/>
           <a:p>
-            <a:pPr marL="0" indent="0" algn="r">
+            <a:pPr algn="r" indent="0" marL="0">
               <a:buNone/>
             </a:pPr>
             <a:r>
@@ -4762,13 +4735,6 @@
             <a:prstDash val="solid"/>
           </a:ln>
         </p:spPr>
-        <p:txBody>
-          <a:bodyPr/>
-          <a:lstStyle/>
-          <a:p>
-            <a:endParaRPr lang="en-US"/>
-          </a:p>
-        </p:txBody>
       </p:sp>
       <p:sp>
         <p:nvSpPr>
@@ -4791,7 +4757,7 @@
           <a:bodyPr wrap="square" lIns="0" tIns="0" rIns="0" bIns="0" rtlCol="0" anchor="ctr"/>
           <a:lstStyle/>
           <a:p>
-            <a:pPr marL="0" indent="0">
+            <a:pPr indent="0" marL="0">
               <a:buNone/>
             </a:pPr>
             <a:r>
@@ -4830,7 +4796,7 @@
           <a:bodyPr wrap="square" lIns="0" tIns="0" rIns="0" bIns="0" rtlCol="0" anchor="ctr"/>
           <a:lstStyle/>
           <a:p>
-            <a:pPr marL="0" indent="0">
+            <a:pPr indent="0" marL="0">
               <a:buNone/>
             </a:pPr>
             <a:r>
@@ -4869,7 +4835,7 @@
           <a:bodyPr wrap="square" lIns="0" tIns="0" rIns="0" bIns="0" rtlCol="0" anchor="ctr"/>
           <a:lstStyle/>
           <a:p>
-            <a:pPr marL="0" indent="0" algn="r">
+            <a:pPr algn="r" indent="0" marL="0">
               <a:buNone/>
             </a:pPr>
             <a:r>
@@ -4913,13 +4879,6 @@
             <a:prstDash val="solid"/>
           </a:ln>
         </p:spPr>
-        <p:txBody>
-          <a:bodyPr/>
-          <a:lstStyle/>
-          <a:p>
-            <a:endParaRPr lang="en-US"/>
-          </a:p>
-        </p:txBody>
       </p:sp>
       <p:sp>
         <p:nvSpPr>
@@ -4942,7 +4901,7 @@
           <a:bodyPr wrap="square" lIns="0" tIns="0" rIns="0" bIns="0" rtlCol="0" anchor="ctr"/>
           <a:lstStyle/>
           <a:p>
-            <a:pPr marL="0" indent="0">
+            <a:pPr indent="0" marL="0">
               <a:buNone/>
             </a:pPr>
             <a:r>
@@ -4981,7 +4940,7 @@
           <a:bodyPr wrap="square" lIns="0" tIns="0" rIns="0" bIns="0" rtlCol="0" anchor="ctr"/>
           <a:lstStyle/>
           <a:p>
-            <a:pPr marL="0" indent="0">
+            <a:pPr indent="0" marL="0">
               <a:buNone/>
             </a:pPr>
             <a:r>
@@ -5020,7 +4979,7 @@
           <a:bodyPr wrap="square" lIns="0" tIns="0" rIns="0" bIns="0" rtlCol="0" anchor="ctr"/>
           <a:lstStyle/>
           <a:p>
-            <a:pPr marL="0" indent="0" algn="r">
+            <a:pPr algn="r" indent="0" marL="0">
               <a:buNone/>
             </a:pPr>
             <a:r>
@@ -5059,7 +5018,7 @@
           <a:bodyPr wrap="square" lIns="0" tIns="0" rIns="0" bIns="0" rtlCol="0" anchor="ctr"/>
           <a:lstStyle/>
           <a:p>
-            <a:pPr marL="0" indent="0">
+            <a:pPr indent="0" marL="0">
               <a:buNone/>
             </a:pPr>
             <a:r>
@@ -5103,13 +5062,6 @@
             <a:prstDash val="solid"/>
           </a:ln>
         </p:spPr>
-        <p:txBody>
-          <a:bodyPr/>
-          <a:lstStyle/>
-          <a:p>
-            <a:endParaRPr lang="en-US"/>
-          </a:p>
-        </p:txBody>
       </p:sp>
       <p:sp>
         <p:nvSpPr>
@@ -5132,11 +5084,11 @@
           <a:bodyPr wrap="square" lIns="0" tIns="0" rIns="0" bIns="0" rtlCol="0" anchor="ctr"/>
           <a:lstStyle/>
           <a:p>
-            <a:pPr marL="0" indent="0">
-              <a:buNone/>
-            </a:pPr>
-            <a:r>
-              <a:rPr lang="en-US" sz="1050" b="1" kern="0" spc="120" dirty="0">
+            <a:pPr indent="0" marL="0">
+              <a:buNone/>
+            </a:pPr>
+            <a:r>
+              <a:rPr lang="en-US" sz="1050" b="1" spc="120" kern="0" dirty="0">
                 <a:solidFill>
                   <a:srgbClr val="FFCC00"/>
                 </a:solidFill>
@@ -5171,7 +5123,7 @@
           <a:bodyPr wrap="square" lIns="0" tIns="0" rIns="0" bIns="0" rtlCol="0" anchor="ctr"/>
           <a:lstStyle/>
           <a:p>
-            <a:pPr marL="0" indent="0">
+            <a:pPr indent="0" marL="0">
               <a:buNone/>
             </a:pPr>
             <a:r>
@@ -5210,7 +5162,7 @@
           <a:bodyPr wrap="square" lIns="0" tIns="0" rIns="0" bIns="0" rtlCol="0" anchor="ctr"/>
           <a:lstStyle/>
           <a:p>
-            <a:pPr marL="0" indent="0">
+            <a:pPr indent="0" marL="0">
               <a:lnSpc>
                 <a:spcPts val="1700"/>
               </a:lnSpc>
@@ -5252,7 +5204,7 @@
           <a:bodyPr wrap="square" lIns="0" tIns="0" rIns="0" bIns="0" rtlCol="0" anchor="ctr"/>
           <a:lstStyle/>
           <a:p>
-            <a:pPr marL="0" indent="0">
+            <a:pPr indent="0" marL="0">
               <a:lnSpc>
                 <a:spcPts val="1400"/>
               </a:lnSpc>
@@ -5294,7 +5246,7 @@
           <a:bodyPr wrap="square" lIns="0" tIns="0" rIns="0" bIns="0" rtlCol="0" anchor="ctr"/>
           <a:lstStyle/>
           <a:p>
-            <a:pPr marL="0" indent="0">
+            <a:pPr indent="0" marL="0">
               <a:buNone/>
             </a:pPr>
             <a:r>
@@ -5333,7 +5285,7 @@
           <a:bodyPr wrap="square" lIns="0" tIns="0" rIns="0" bIns="0" rtlCol="0" anchor="ctr"/>
           <a:lstStyle/>
           <a:p>
-            <a:pPr marL="0" indent="0" algn="r">
+            <a:pPr algn="r" indent="0" marL="0">
               <a:buNone/>
             </a:pPr>
             <a:r>
@@ -5367,7 +5319,6 @@
         <a:solidFill>
           <a:srgbClr val="FFFFFF"/>
         </a:solidFill>
-        <a:effectLst/>
       </p:bgPr>
     </p:bg>
     <p:spTree>
@@ -5408,13 +5359,6 @@
             <a:prstDash val="solid"/>
           </a:ln>
         </p:spPr>
-        <p:txBody>
-          <a:bodyPr/>
-          <a:lstStyle/>
-          <a:p>
-            <a:endParaRPr lang="en-US"/>
-          </a:p>
-        </p:txBody>
       </p:sp>
       <p:sp>
         <p:nvSpPr>
@@ -5437,7 +5381,7 @@
           <a:bodyPr wrap="square" lIns="0" tIns="0" rIns="0" bIns="0" rtlCol="0" anchor="ctr"/>
           <a:lstStyle/>
           <a:p>
-            <a:pPr marL="0" indent="0" algn="ctr">
+            <a:pPr algn="ctr" indent="0" marL="0">
               <a:buNone/>
             </a:pPr>
             <a:r>
@@ -5476,11 +5420,11 @@
           <a:bodyPr wrap="square" lIns="0" tIns="0" rIns="0" bIns="0" rtlCol="0" anchor="ctr"/>
           <a:lstStyle/>
           <a:p>
-            <a:pPr marL="0" indent="0">
-              <a:buNone/>
-            </a:pPr>
-            <a:r>
-              <a:rPr lang="en-US" sz="1100" b="1" kern="0" spc="200" dirty="0">
+            <a:pPr indent="0" marL="0">
+              <a:buNone/>
+            </a:pPr>
+            <a:r>
+              <a:rPr lang="en-US" sz="1100" b="1" spc="200" kern="0" dirty="0">
                 <a:solidFill>
                   <a:srgbClr val="003399"/>
                 </a:solidFill>
@@ -5515,7 +5459,7 @@
           <a:bodyPr wrap="square" lIns="0" tIns="0" rIns="0" bIns="0" rtlCol="0" anchor="ctr"/>
           <a:lstStyle/>
           <a:p>
-            <a:pPr marL="0" indent="0">
+            <a:pPr indent="0" marL="0">
               <a:buNone/>
             </a:pPr>
             <a:r>
@@ -5554,7 +5498,7 @@
           <a:bodyPr wrap="square" lIns="0" tIns="0" rIns="0" bIns="0" rtlCol="0" anchor="ctr"/>
           <a:lstStyle/>
           <a:p>
-            <a:pPr marL="0" indent="0">
+            <a:pPr indent="0" marL="0">
               <a:buNone/>
             </a:pPr>
             <a:r>
@@ -5598,13 +5542,6 @@
             <a:prstDash val="solid"/>
           </a:ln>
         </p:spPr>
-        <p:txBody>
-          <a:bodyPr/>
-          <a:lstStyle/>
-          <a:p>
-            <a:endParaRPr lang="en-US"/>
-          </a:p>
-        </p:txBody>
       </p:sp>
       <p:sp>
         <p:nvSpPr>
@@ -5630,13 +5567,6 @@
             <a:prstDash val="solid"/>
           </a:ln>
         </p:spPr>
-        <p:txBody>
-          <a:bodyPr/>
-          <a:lstStyle/>
-          <a:p>
-            <a:endParaRPr lang="en-US"/>
-          </a:p>
-        </p:txBody>
       </p:sp>
       <p:sp>
         <p:nvSpPr>
@@ -5659,7 +5589,7 @@
           <a:bodyPr wrap="square" lIns="0" tIns="0" rIns="0" bIns="0" rtlCol="0" anchor="ctr"/>
           <a:lstStyle/>
           <a:p>
-            <a:pPr marL="0" indent="0" algn="ctr">
+            <a:pPr algn="ctr" indent="0" marL="0">
               <a:buNone/>
             </a:pPr>
             <a:r>
@@ -5698,7 +5628,7 @@
           <a:bodyPr wrap="square" lIns="0" tIns="0" rIns="0" bIns="0" rtlCol="0" anchor="ctr"/>
           <a:lstStyle/>
           <a:p>
-            <a:pPr marL="0" indent="0">
+            <a:pPr indent="0" marL="0">
               <a:buNone/>
             </a:pPr>
             <a:r>
@@ -5737,7 +5667,7 @@
           <a:bodyPr wrap="square" lIns="0" tIns="0" rIns="0" bIns="0" rtlCol="0" anchor="ctr"/>
           <a:lstStyle/>
           <a:p>
-            <a:pPr marL="0" indent="0">
+            <a:pPr indent="0" marL="0">
               <a:lnSpc>
                 <a:spcPts val="2000"/>
               </a:lnSpc>
@@ -5784,13 +5714,6 @@
             <a:prstDash val="solid"/>
           </a:ln>
         </p:spPr>
-        <p:txBody>
-          <a:bodyPr/>
-          <a:lstStyle/>
-          <a:p>
-            <a:endParaRPr lang="en-US"/>
-          </a:p>
-        </p:txBody>
       </p:sp>
       <p:sp>
         <p:nvSpPr>
@@ -5816,13 +5739,6 @@
             <a:prstDash val="solid"/>
           </a:ln>
         </p:spPr>
-        <p:txBody>
-          <a:bodyPr/>
-          <a:lstStyle/>
-          <a:p>
-            <a:endParaRPr lang="en-US"/>
-          </a:p>
-        </p:txBody>
       </p:sp>
       <p:sp>
         <p:nvSpPr>
@@ -5845,7 +5761,7 @@
           <a:bodyPr wrap="square" lIns="0" tIns="0" rIns="0" bIns="0" rtlCol="0" anchor="ctr"/>
           <a:lstStyle/>
           <a:p>
-            <a:pPr marL="0" indent="0" algn="ctr">
+            <a:pPr algn="ctr" indent="0" marL="0">
               <a:buNone/>
             </a:pPr>
             <a:r>
@@ -5884,7 +5800,7 @@
           <a:bodyPr wrap="square" lIns="0" tIns="0" rIns="0" bIns="0" rtlCol="0" anchor="ctr"/>
           <a:lstStyle/>
           <a:p>
-            <a:pPr marL="0" indent="0">
+            <a:pPr indent="0" marL="0">
               <a:buNone/>
             </a:pPr>
             <a:r>
@@ -5923,7 +5839,7 @@
           <a:bodyPr wrap="square" lIns="0" tIns="0" rIns="0" bIns="0" rtlCol="0" anchor="ctr"/>
           <a:lstStyle/>
           <a:p>
-            <a:pPr marL="0" indent="0">
+            <a:pPr indent="0" marL="0">
               <a:lnSpc>
                 <a:spcPts val="2000"/>
               </a:lnSpc>
@@ -5970,13 +5886,6 @@
             <a:prstDash val="solid"/>
           </a:ln>
         </p:spPr>
-        <p:txBody>
-          <a:bodyPr/>
-          <a:lstStyle/>
-          <a:p>
-            <a:endParaRPr lang="en-US"/>
-          </a:p>
-        </p:txBody>
       </p:sp>
       <p:sp>
         <p:nvSpPr>
@@ -6002,13 +5911,6 @@
             <a:prstDash val="solid"/>
           </a:ln>
         </p:spPr>
-        <p:txBody>
-          <a:bodyPr/>
-          <a:lstStyle/>
-          <a:p>
-            <a:endParaRPr lang="en-US"/>
-          </a:p>
-        </p:txBody>
       </p:sp>
       <p:sp>
         <p:nvSpPr>
@@ -6031,7 +5933,7 @@
           <a:bodyPr wrap="square" lIns="0" tIns="0" rIns="0" bIns="0" rtlCol="0" anchor="ctr"/>
           <a:lstStyle/>
           <a:p>
-            <a:pPr marL="0" indent="0" algn="ctr">
+            <a:pPr algn="ctr" indent="0" marL="0">
               <a:buNone/>
             </a:pPr>
             <a:r>
@@ -6070,7 +5972,7 @@
           <a:bodyPr wrap="square" lIns="0" tIns="0" rIns="0" bIns="0" rtlCol="0" anchor="ctr"/>
           <a:lstStyle/>
           <a:p>
-            <a:pPr marL="0" indent="0">
+            <a:pPr indent="0" marL="0">
               <a:buNone/>
             </a:pPr>
             <a:r>
@@ -6109,7 +6011,7 @@
           <a:bodyPr wrap="square" lIns="0" tIns="0" rIns="0" bIns="0" rtlCol="0" anchor="ctr"/>
           <a:lstStyle/>
           <a:p>
-            <a:pPr marL="0" indent="0">
+            <a:pPr indent="0" marL="0">
               <a:lnSpc>
                 <a:spcPts val="2000"/>
               </a:lnSpc>
@@ -6156,13 +6058,6 @@
             <a:prstDash val="solid"/>
           </a:ln>
         </p:spPr>
-        <p:txBody>
-          <a:bodyPr/>
-          <a:lstStyle/>
-          <a:p>
-            <a:endParaRPr lang="en-US"/>
-          </a:p>
-        </p:txBody>
       </p:sp>
       <p:sp>
         <p:nvSpPr>
@@ -6185,7 +6080,7 @@
           <a:bodyPr wrap="square" lIns="0" tIns="0" rIns="0" bIns="0" rtlCol="0" anchor="ctr"/>
           <a:lstStyle/>
           <a:p>
-            <a:pPr marL="0" indent="0">
+            <a:pPr indent="0" marL="0">
               <a:buNone/>
             </a:pPr>
             <a:r>
@@ -6224,7 +6119,7 @@
           <a:bodyPr wrap="square" lIns="0" tIns="0" rIns="0" bIns="0" rtlCol="0" anchor="ctr"/>
           <a:lstStyle/>
           <a:p>
-            <a:pPr marL="0" indent="0">
+            <a:pPr indent="0" marL="0">
               <a:buNone/>
             </a:pPr>
             <a:r>
@@ -6263,7 +6158,7 @@
           <a:bodyPr wrap="square" lIns="0" tIns="0" rIns="0" bIns="0" rtlCol="0" anchor="ctr"/>
           <a:lstStyle/>
           <a:p>
-            <a:pPr marL="0" indent="0" algn="r">
+            <a:pPr algn="r" indent="0" marL="0">
               <a:buNone/>
             </a:pPr>
             <a:r>
@@ -6297,7 +6192,6 @@
         <a:solidFill>
           <a:srgbClr val="FFFFFF"/>
         </a:solidFill>
-        <a:effectLst/>
       </p:bgPr>
     </p:bg>
     <p:spTree>
@@ -6338,13 +6232,6 @@
             <a:prstDash val="solid"/>
           </a:ln>
         </p:spPr>
-        <p:txBody>
-          <a:bodyPr/>
-          <a:lstStyle/>
-          <a:p>
-            <a:endParaRPr lang="en-US"/>
-          </a:p>
-        </p:txBody>
       </p:sp>
       <p:sp>
         <p:nvSpPr>
@@ -6367,7 +6254,7 @@
           <a:bodyPr wrap="square" lIns="0" tIns="0" rIns="0" bIns="0" rtlCol="0" anchor="ctr"/>
           <a:lstStyle/>
           <a:p>
-            <a:pPr marL="0" indent="0" algn="ctr">
+            <a:pPr algn="ctr" indent="0" marL="0">
               <a:buNone/>
             </a:pPr>
             <a:r>
@@ -6406,11 +6293,11 @@
           <a:bodyPr wrap="square" lIns="0" tIns="0" rIns="0" bIns="0" rtlCol="0" anchor="ctr"/>
           <a:lstStyle/>
           <a:p>
-            <a:pPr marL="0" indent="0">
-              <a:buNone/>
-            </a:pPr>
-            <a:r>
-              <a:rPr lang="en-US" sz="1100" b="1" kern="0" spc="200" dirty="0">
+            <a:pPr indent="0" marL="0">
+              <a:buNone/>
+            </a:pPr>
+            <a:r>
+              <a:rPr lang="en-US" sz="1100" b="1" spc="200" kern="0" dirty="0">
                 <a:solidFill>
                   <a:srgbClr val="003399"/>
                 </a:solidFill>
@@ -6445,7 +6332,7 @@
           <a:bodyPr wrap="square" lIns="0" tIns="0" rIns="0" bIns="0" rtlCol="0" anchor="ctr"/>
           <a:lstStyle/>
           <a:p>
-            <a:pPr marL="0" indent="0">
+            <a:pPr indent="0" marL="0">
               <a:buNone/>
             </a:pPr>
             <a:r>
@@ -6484,7 +6371,7 @@
           <a:bodyPr wrap="square" lIns="0" tIns="0" rIns="0" bIns="0" rtlCol="0" anchor="ctr"/>
           <a:lstStyle/>
           <a:p>
-            <a:pPr marL="0" indent="0">
+            <a:pPr indent="0" marL="0">
               <a:buNone/>
             </a:pPr>
             <a:r>
@@ -6528,13 +6415,6 @@
             <a:prstDash val="solid"/>
           </a:ln>
         </p:spPr>
-        <p:txBody>
-          <a:bodyPr/>
-          <a:lstStyle/>
-          <a:p>
-            <a:endParaRPr lang="en-US"/>
-          </a:p>
-        </p:txBody>
       </p:sp>
       <p:sp>
         <p:nvSpPr>
@@ -6560,13 +6440,6 @@
             <a:prstDash val="solid"/>
           </a:ln>
         </p:spPr>
-        <p:txBody>
-          <a:bodyPr/>
-          <a:lstStyle/>
-          <a:p>
-            <a:endParaRPr lang="en-US"/>
-          </a:p>
-        </p:txBody>
       </p:sp>
       <p:sp>
         <p:nvSpPr>
@@ -6589,7 +6462,7 @@
           <a:bodyPr wrap="square" lIns="0" tIns="0" rIns="0" bIns="0" rtlCol="0" anchor="ctr"/>
           <a:lstStyle/>
           <a:p>
-            <a:pPr marL="0" indent="0" algn="ctr">
+            <a:pPr algn="ctr" indent="0" marL="0">
               <a:buNone/>
             </a:pPr>
             <a:r>
@@ -6628,7 +6501,7 @@
           <a:bodyPr wrap="square" lIns="0" tIns="0" rIns="0" bIns="0" rtlCol="0" anchor="ctr"/>
           <a:lstStyle/>
           <a:p>
-            <a:pPr marL="0" indent="0" algn="ctr">
+            <a:pPr algn="ctr" indent="0" marL="0">
               <a:buNone/>
             </a:pPr>
             <a:r>
@@ -6667,7 +6540,7 @@
           <a:bodyPr wrap="square" lIns="0" tIns="0" rIns="0" bIns="0" rtlCol="0" anchor="ctr"/>
           <a:lstStyle/>
           <a:p>
-            <a:pPr marL="0" indent="0" algn="ctr">
+            <a:pPr algn="ctr" indent="0" marL="0">
               <a:lnSpc>
                 <a:spcPts val="1700"/>
               </a:lnSpc>
@@ -6712,13 +6585,6 @@
             <a:prstDash val="solid"/>
           </a:ln>
         </p:spPr>
-        <p:txBody>
-          <a:bodyPr/>
-          <a:lstStyle/>
-          <a:p>
-            <a:endParaRPr lang="en-US"/>
-          </a:p>
-        </p:txBody>
       </p:sp>
       <p:sp>
         <p:nvSpPr>
@@ -6746,13 +6612,6 @@
             <a:prstDash val="solid"/>
           </a:ln>
         </p:spPr>
-        <p:txBody>
-          <a:bodyPr/>
-          <a:lstStyle/>
-          <a:p>
-            <a:endParaRPr lang="en-US"/>
-          </a:p>
-        </p:txBody>
       </p:sp>
       <p:sp>
         <p:nvSpPr>
@@ -6778,13 +6637,6 @@
             <a:prstDash val="solid"/>
           </a:ln>
         </p:spPr>
-        <p:txBody>
-          <a:bodyPr/>
-          <a:lstStyle/>
-          <a:p>
-            <a:endParaRPr lang="en-US"/>
-          </a:p>
-        </p:txBody>
       </p:sp>
       <p:sp>
         <p:nvSpPr>
@@ -6807,7 +6659,7 @@
           <a:bodyPr wrap="square" lIns="0" tIns="0" rIns="0" bIns="0" rtlCol="0" anchor="ctr"/>
           <a:lstStyle/>
           <a:p>
-            <a:pPr marL="0" indent="0" algn="ctr">
+            <a:pPr algn="ctr" indent="0" marL="0">
               <a:buNone/>
             </a:pPr>
             <a:r>
@@ -6846,7 +6698,7 @@
           <a:bodyPr wrap="square" lIns="0" tIns="0" rIns="0" bIns="0" rtlCol="0" anchor="ctr"/>
           <a:lstStyle/>
           <a:p>
-            <a:pPr marL="0" indent="0" algn="ctr">
+            <a:pPr algn="ctr" indent="0" marL="0">
               <a:buNone/>
             </a:pPr>
             <a:r>
@@ -6885,7 +6737,7 @@
           <a:bodyPr wrap="square" lIns="0" tIns="0" rIns="0" bIns="0" rtlCol="0" anchor="ctr"/>
           <a:lstStyle/>
           <a:p>
-            <a:pPr marL="0" indent="0" algn="ctr">
+            <a:pPr algn="ctr" indent="0" marL="0">
               <a:lnSpc>
                 <a:spcPts val="1700"/>
               </a:lnSpc>
@@ -6930,13 +6782,6 @@
             <a:prstDash val="solid"/>
           </a:ln>
         </p:spPr>
-        <p:txBody>
-          <a:bodyPr/>
-          <a:lstStyle/>
-          <a:p>
-            <a:endParaRPr lang="en-US"/>
-          </a:p>
-        </p:txBody>
       </p:sp>
       <p:sp>
         <p:nvSpPr>
@@ -6964,13 +6809,6 @@
             <a:prstDash val="solid"/>
           </a:ln>
         </p:spPr>
-        <p:txBody>
-          <a:bodyPr/>
-          <a:lstStyle/>
-          <a:p>
-            <a:endParaRPr lang="en-US"/>
-          </a:p>
-        </p:txBody>
       </p:sp>
       <p:sp>
         <p:nvSpPr>
@@ -6996,13 +6834,6 @@
             <a:prstDash val="solid"/>
           </a:ln>
         </p:spPr>
-        <p:txBody>
-          <a:bodyPr/>
-          <a:lstStyle/>
-          <a:p>
-            <a:endParaRPr lang="en-US"/>
-          </a:p>
-        </p:txBody>
       </p:sp>
       <p:sp>
         <p:nvSpPr>
@@ -7025,7 +6856,7 @@
           <a:bodyPr wrap="square" lIns="0" tIns="0" rIns="0" bIns="0" rtlCol="0" anchor="ctr"/>
           <a:lstStyle/>
           <a:p>
-            <a:pPr marL="0" indent="0" algn="ctr">
+            <a:pPr algn="ctr" indent="0" marL="0">
               <a:buNone/>
             </a:pPr>
             <a:r>
@@ -7064,7 +6895,7 @@
           <a:bodyPr wrap="square" lIns="0" tIns="0" rIns="0" bIns="0" rtlCol="0" anchor="ctr"/>
           <a:lstStyle/>
           <a:p>
-            <a:pPr marL="0" indent="0" algn="ctr">
+            <a:pPr algn="ctr" indent="0" marL="0">
               <a:buNone/>
             </a:pPr>
             <a:r>
@@ -7103,7 +6934,7 @@
           <a:bodyPr wrap="square" lIns="0" tIns="0" rIns="0" bIns="0" rtlCol="0" anchor="ctr"/>
           <a:lstStyle/>
           <a:p>
-            <a:pPr marL="0" indent="0" algn="ctr">
+            <a:pPr algn="ctr" indent="0" marL="0">
               <a:lnSpc>
                 <a:spcPts val="1700"/>
               </a:lnSpc>
@@ -7148,13 +6979,6 @@
             <a:prstDash val="solid"/>
           </a:ln>
         </p:spPr>
-        <p:txBody>
-          <a:bodyPr/>
-          <a:lstStyle/>
-          <a:p>
-            <a:endParaRPr lang="en-US"/>
-          </a:p>
-        </p:txBody>
       </p:sp>
       <p:sp>
         <p:nvSpPr>
@@ -7182,13 +7006,6 @@
             <a:prstDash val="solid"/>
           </a:ln>
         </p:spPr>
-        <p:txBody>
-          <a:bodyPr/>
-          <a:lstStyle/>
-          <a:p>
-            <a:endParaRPr lang="en-US"/>
-          </a:p>
-        </p:txBody>
       </p:sp>
       <p:sp>
         <p:nvSpPr>
@@ -7214,13 +7031,6 @@
             <a:prstDash val="solid"/>
           </a:ln>
         </p:spPr>
-        <p:txBody>
-          <a:bodyPr/>
-          <a:lstStyle/>
-          <a:p>
-            <a:endParaRPr lang="en-US"/>
-          </a:p>
-        </p:txBody>
       </p:sp>
       <p:sp>
         <p:nvSpPr>
@@ -7243,7 +7053,7 @@
           <a:bodyPr wrap="square" lIns="0" tIns="0" rIns="0" bIns="0" rtlCol="0" anchor="ctr"/>
           <a:lstStyle/>
           <a:p>
-            <a:pPr marL="0" indent="0" algn="ctr">
+            <a:pPr algn="ctr" indent="0" marL="0">
               <a:buNone/>
             </a:pPr>
             <a:r>
@@ -7282,7 +7092,7 @@
           <a:bodyPr wrap="square" lIns="0" tIns="0" rIns="0" bIns="0" rtlCol="0" anchor="ctr"/>
           <a:lstStyle/>
           <a:p>
-            <a:pPr marL="0" indent="0" algn="ctr">
+            <a:pPr algn="ctr" indent="0" marL="0">
               <a:buNone/>
             </a:pPr>
             <a:r>
@@ -7321,7 +7131,7 @@
           <a:bodyPr wrap="square" lIns="0" tIns="0" rIns="0" bIns="0" rtlCol="0" anchor="ctr"/>
           <a:lstStyle/>
           <a:p>
-            <a:pPr marL="0" indent="0" algn="ctr">
+            <a:pPr algn="ctr" indent="0" marL="0">
               <a:lnSpc>
                 <a:spcPts val="1700"/>
               </a:lnSpc>
@@ -7366,13 +7176,6 @@
             <a:prstDash val="solid"/>
           </a:ln>
         </p:spPr>
-        <p:txBody>
-          <a:bodyPr/>
-          <a:lstStyle/>
-          <a:p>
-            <a:endParaRPr lang="en-US"/>
-          </a:p>
-        </p:txBody>
       </p:sp>
       <p:sp>
         <p:nvSpPr>
@@ -7400,13 +7203,6 @@
             <a:prstDash val="solid"/>
           </a:ln>
         </p:spPr>
-        <p:txBody>
-          <a:bodyPr/>
-          <a:lstStyle/>
-          <a:p>
-            <a:endParaRPr lang="en-US"/>
-          </a:p>
-        </p:txBody>
       </p:sp>
       <p:sp>
         <p:nvSpPr>
@@ -7432,13 +7228,6 @@
             <a:prstDash val="solid"/>
           </a:ln>
         </p:spPr>
-        <p:txBody>
-          <a:bodyPr/>
-          <a:lstStyle/>
-          <a:p>
-            <a:endParaRPr lang="en-US"/>
-          </a:p>
-        </p:txBody>
       </p:sp>
       <p:sp>
         <p:nvSpPr>
@@ -7461,7 +7250,7 @@
           <a:bodyPr wrap="square" lIns="0" tIns="0" rIns="0" bIns="0" rtlCol="0" anchor="ctr"/>
           <a:lstStyle/>
           <a:p>
-            <a:pPr marL="0" indent="0" algn="ctr">
+            <a:pPr algn="ctr" indent="0" marL="0">
               <a:buNone/>
             </a:pPr>
             <a:r>
@@ -7500,7 +7289,7 @@
           <a:bodyPr wrap="square" lIns="0" tIns="0" rIns="0" bIns="0" rtlCol="0" anchor="ctr"/>
           <a:lstStyle/>
           <a:p>
-            <a:pPr marL="0" indent="0" algn="ctr">
+            <a:pPr algn="ctr" indent="0" marL="0">
               <a:buNone/>
             </a:pPr>
             <a:r>
@@ -7539,7 +7328,7 @@
           <a:bodyPr wrap="square" lIns="0" tIns="0" rIns="0" bIns="0" rtlCol="0" anchor="ctr"/>
           <a:lstStyle/>
           <a:p>
-            <a:pPr marL="0" indent="0" algn="ctr">
+            <a:pPr algn="ctr" indent="0" marL="0">
               <a:lnSpc>
                 <a:spcPts val="1700"/>
               </a:lnSpc>
@@ -7586,13 +7375,6 @@
             <a:prstDash val="solid"/>
           </a:ln>
         </p:spPr>
-        <p:txBody>
-          <a:bodyPr/>
-          <a:lstStyle/>
-          <a:p>
-            <a:endParaRPr lang="en-US"/>
-          </a:p>
-        </p:txBody>
       </p:sp>
       <p:sp>
         <p:nvSpPr>
@@ -7615,11 +7397,11 @@
           <a:bodyPr wrap="square" lIns="0" tIns="0" rIns="0" bIns="0" rtlCol="0" anchor="ctr"/>
           <a:lstStyle/>
           <a:p>
-            <a:pPr marL="0" indent="0">
-              <a:buNone/>
-            </a:pPr>
-            <a:r>
-              <a:rPr lang="en-US" sz="1200" b="1" kern="0" spc="120" dirty="0">
+            <a:pPr indent="0" marL="0">
+              <a:buNone/>
+            </a:pPr>
+            <a:r>
+              <a:rPr lang="en-US" sz="1200" b="1" spc="120" kern="0" dirty="0">
                 <a:solidFill>
                   <a:srgbClr val="FFCC00"/>
                 </a:solidFill>
@@ -7654,7 +7436,7 @@
           <a:bodyPr wrap="square" lIns="0" tIns="0" rIns="0" bIns="0" rtlCol="0" anchor="ctr"/>
           <a:lstStyle/>
           <a:p>
-            <a:pPr marL="0" indent="0">
+            <a:pPr indent="0" marL="0">
               <a:buNone/>
             </a:pPr>
             <a:r>
@@ -7693,7 +7475,7 @@
           <a:bodyPr wrap="square" lIns="0" tIns="0" rIns="0" bIns="0" rtlCol="0" anchor="ctr"/>
           <a:lstStyle/>
           <a:p>
-            <a:pPr marL="0" indent="0">
+            <a:pPr indent="0" marL="0">
               <a:buNone/>
             </a:pPr>
             <a:r>
@@ -7732,7 +7514,7 @@
           <a:bodyPr wrap="square" lIns="0" tIns="0" rIns="0" bIns="0" rtlCol="0" anchor="ctr"/>
           <a:lstStyle/>
           <a:p>
-            <a:pPr marL="0" indent="0" algn="r">
+            <a:pPr algn="r" indent="0" marL="0">
               <a:buNone/>
             </a:pPr>
             <a:r>
@@ -7766,7 +7548,6 @@
         <a:solidFill>
           <a:srgbClr val="FFFFFF"/>
         </a:solidFill>
-        <a:effectLst/>
       </p:bgPr>
     </p:bg>
     <p:spTree>
@@ -7807,13 +7588,6 @@
             <a:prstDash val="solid"/>
           </a:ln>
         </p:spPr>
-        <p:txBody>
-          <a:bodyPr/>
-          <a:lstStyle/>
-          <a:p>
-            <a:endParaRPr lang="en-US"/>
-          </a:p>
-        </p:txBody>
       </p:sp>
       <p:sp>
         <p:nvSpPr>
@@ -7836,7 +7610,7 @@
           <a:bodyPr wrap="square" lIns="0" tIns="0" rIns="0" bIns="0" rtlCol="0" anchor="ctr"/>
           <a:lstStyle/>
           <a:p>
-            <a:pPr marL="0" indent="0" algn="ctr">
+            <a:pPr algn="ctr" indent="0" marL="0">
               <a:buNone/>
             </a:pPr>
             <a:r>
@@ -7875,11 +7649,11 @@
           <a:bodyPr wrap="square" lIns="0" tIns="0" rIns="0" bIns="0" rtlCol="0" anchor="ctr"/>
           <a:lstStyle/>
           <a:p>
-            <a:pPr marL="0" indent="0">
-              <a:buNone/>
-            </a:pPr>
-            <a:r>
-              <a:rPr lang="en-US" sz="1100" b="1" kern="0" spc="200" dirty="0">
+            <a:pPr indent="0" marL="0">
+              <a:buNone/>
+            </a:pPr>
+            <a:r>
+              <a:rPr lang="en-US" sz="1100" b="1" spc="200" kern="0" dirty="0">
                 <a:solidFill>
                   <a:srgbClr val="003399"/>
                 </a:solidFill>
@@ -7914,7 +7688,7 @@
           <a:bodyPr wrap="square" lIns="0" tIns="0" rIns="0" bIns="0" rtlCol="0" anchor="ctr"/>
           <a:lstStyle/>
           <a:p>
-            <a:pPr marL="0" indent="0">
+            <a:pPr indent="0" marL="0">
               <a:buNone/>
             </a:pPr>
             <a:r>
@@ -7953,7 +7727,7 @@
           <a:bodyPr wrap="square" lIns="0" tIns="0" rIns="0" bIns="0" rtlCol="0" anchor="ctr"/>
           <a:lstStyle/>
           <a:p>
-            <a:pPr marL="0" indent="0">
+            <a:pPr indent="0" marL="0">
               <a:buNone/>
             </a:pPr>
             <a:r>
@@ -7997,13 +7771,6 @@
             <a:prstDash val="solid"/>
           </a:ln>
         </p:spPr>
-        <p:txBody>
-          <a:bodyPr/>
-          <a:lstStyle/>
-          <a:p>
-            <a:endParaRPr lang="en-US"/>
-          </a:p>
-        </p:txBody>
       </p:sp>
       <p:sp>
         <p:nvSpPr>
@@ -8029,13 +7796,6 @@
             <a:prstDash val="solid"/>
           </a:ln>
         </p:spPr>
-        <p:txBody>
-          <a:bodyPr/>
-          <a:lstStyle/>
-          <a:p>
-            <a:endParaRPr lang="en-US"/>
-          </a:p>
-        </p:txBody>
       </p:sp>
       <p:sp>
         <p:nvSpPr>
@@ -8061,13 +7821,6 @@
             <a:prstDash val="solid"/>
           </a:ln>
         </p:spPr>
-        <p:txBody>
-          <a:bodyPr/>
-          <a:lstStyle/>
-          <a:p>
-            <a:endParaRPr lang="en-US"/>
-          </a:p>
-        </p:txBody>
       </p:sp>
       <p:sp>
         <p:nvSpPr>
@@ -8090,7 +7843,7 @@
           <a:bodyPr wrap="square" lIns="0" tIns="0" rIns="0" bIns="0" rtlCol="0" anchor="ctr"/>
           <a:lstStyle/>
           <a:p>
-            <a:pPr marL="0" indent="0">
+            <a:pPr indent="0" marL="0">
               <a:buNone/>
             </a:pPr>
             <a:r>
@@ -8219,13 +7972,6 @@
             <a:prstDash val="solid"/>
           </a:ln>
         </p:spPr>
-        <p:txBody>
-          <a:bodyPr/>
-          <a:lstStyle/>
-          <a:p>
-            <a:endParaRPr lang="en-US"/>
-          </a:p>
-        </p:txBody>
       </p:sp>
       <p:sp>
         <p:nvSpPr>
@@ -8251,13 +7997,6 @@
             <a:prstDash val="solid"/>
           </a:ln>
         </p:spPr>
-        <p:txBody>
-          <a:bodyPr/>
-          <a:lstStyle/>
-          <a:p>
-            <a:endParaRPr lang="en-US"/>
-          </a:p>
-        </p:txBody>
       </p:sp>
       <p:sp>
         <p:nvSpPr>
@@ -8283,13 +8022,6 @@
             <a:prstDash val="solid"/>
           </a:ln>
         </p:spPr>
-        <p:txBody>
-          <a:bodyPr/>
-          <a:lstStyle/>
-          <a:p>
-            <a:endParaRPr lang="en-US"/>
-          </a:p>
-        </p:txBody>
       </p:sp>
       <p:sp>
         <p:nvSpPr>
@@ -8312,7 +8044,7 @@
           <a:bodyPr wrap="square" lIns="0" tIns="0" rIns="0" bIns="0" rtlCol="0" anchor="ctr"/>
           <a:lstStyle/>
           <a:p>
-            <a:pPr marL="0" indent="0">
+            <a:pPr indent="0" marL="0">
               <a:buNone/>
             </a:pPr>
             <a:r>
@@ -8441,13 +8173,6 @@
             <a:prstDash val="solid"/>
           </a:ln>
         </p:spPr>
-        <p:txBody>
-          <a:bodyPr/>
-          <a:lstStyle/>
-          <a:p>
-            <a:endParaRPr lang="en-US"/>
-          </a:p>
-        </p:txBody>
       </p:sp>
       <p:sp>
         <p:nvSpPr>
@@ -8473,13 +8198,6 @@
             <a:prstDash val="solid"/>
           </a:ln>
         </p:spPr>
-        <p:txBody>
-          <a:bodyPr/>
-          <a:lstStyle/>
-          <a:p>
-            <a:endParaRPr lang="en-US"/>
-          </a:p>
-        </p:txBody>
       </p:sp>
       <p:sp>
         <p:nvSpPr>
@@ -8505,13 +8223,6 @@
             <a:prstDash val="solid"/>
           </a:ln>
         </p:spPr>
-        <p:txBody>
-          <a:bodyPr/>
-          <a:lstStyle/>
-          <a:p>
-            <a:endParaRPr lang="en-US"/>
-          </a:p>
-        </p:txBody>
       </p:sp>
       <p:sp>
         <p:nvSpPr>
@@ -8534,7 +8245,7 @@
           <a:bodyPr wrap="square" lIns="0" tIns="0" rIns="0" bIns="0" rtlCol="0" anchor="ctr"/>
           <a:lstStyle/>
           <a:p>
-            <a:pPr marL="0" indent="0">
+            <a:pPr indent="0" marL="0">
               <a:buNone/>
             </a:pPr>
             <a:r>
@@ -8663,13 +8374,6 @@
             <a:prstDash val="solid"/>
           </a:ln>
         </p:spPr>
-        <p:txBody>
-          <a:bodyPr/>
-          <a:lstStyle/>
-          <a:p>
-            <a:endParaRPr lang="en-US"/>
-          </a:p>
-        </p:txBody>
       </p:sp>
       <p:sp>
         <p:nvSpPr>
@@ -8695,13 +8399,6 @@
             <a:prstDash val="solid"/>
           </a:ln>
         </p:spPr>
-        <p:txBody>
-          <a:bodyPr/>
-          <a:lstStyle/>
-          <a:p>
-            <a:endParaRPr lang="en-US"/>
-          </a:p>
-        </p:txBody>
       </p:sp>
       <p:sp>
         <p:nvSpPr>
@@ -8727,13 +8424,6 @@
             <a:prstDash val="solid"/>
           </a:ln>
         </p:spPr>
-        <p:txBody>
-          <a:bodyPr/>
-          <a:lstStyle/>
-          <a:p>
-            <a:endParaRPr lang="en-US"/>
-          </a:p>
-        </p:txBody>
       </p:sp>
       <p:sp>
         <p:nvSpPr>
@@ -8756,7 +8446,7 @@
           <a:bodyPr wrap="square" lIns="0" tIns="0" rIns="0" bIns="0" rtlCol="0" anchor="ctr"/>
           <a:lstStyle/>
           <a:p>
-            <a:pPr marL="0" indent="0">
+            <a:pPr indent="0" marL="0">
               <a:buNone/>
             </a:pPr>
             <a:r>
@@ -8885,13 +8575,6 @@
             <a:prstDash val="solid"/>
           </a:ln>
         </p:spPr>
-        <p:txBody>
-          <a:bodyPr/>
-          <a:lstStyle/>
-          <a:p>
-            <a:endParaRPr lang="en-US"/>
-          </a:p>
-        </p:txBody>
       </p:sp>
       <p:sp>
         <p:nvSpPr>
@@ -8914,11 +8597,11 @@
           <a:bodyPr wrap="square" lIns="0" tIns="0" rIns="0" bIns="0" rtlCol="0" anchor="ctr"/>
           <a:lstStyle/>
           <a:p>
-            <a:pPr marL="0" indent="0">
-              <a:buNone/>
-            </a:pPr>
-            <a:r>
-              <a:rPr lang="en-US" sz="1700" b="1" kern="0" spc="150" dirty="0">
+            <a:pPr indent="0" marL="0">
+              <a:buNone/>
+            </a:pPr>
+            <a:r>
+              <a:rPr lang="en-US" sz="1700" b="1" spc="150" kern="0" dirty="0">
                 <a:solidFill>
                   <a:srgbClr val="FFCC00"/>
                 </a:solidFill>
@@ -8953,7 +8636,7 @@
           <a:bodyPr wrap="square" lIns="0" tIns="0" rIns="0" bIns="0" rtlCol="0" anchor="ctr"/>
           <a:lstStyle/>
           <a:p>
-            <a:pPr marL="0" indent="0" algn="r">
+            <a:pPr algn="r" indent="0" marL="0">
               <a:buNone/>
             </a:pPr>
             <a:r>
@@ -8992,7 +8675,7 @@
           <a:bodyPr wrap="square" lIns="0" tIns="0" rIns="0" bIns="0" rtlCol="0" anchor="ctr"/>
           <a:lstStyle/>
           <a:p>
-            <a:pPr marL="0" indent="0">
+            <a:pPr indent="0" marL="0">
               <a:buNone/>
             </a:pPr>
             <a:r>
@@ -9031,7 +8714,7 @@
           <a:bodyPr wrap="square" lIns="0" tIns="0" rIns="0" bIns="0" rtlCol="0" anchor="ctr"/>
           <a:lstStyle/>
           <a:p>
-            <a:pPr marL="0" indent="0" algn="r">
+            <a:pPr algn="r" indent="0" marL="0">
               <a:buNone/>
             </a:pPr>
             <a:r>
@@ -9065,7 +8748,6 @@
         <a:solidFill>
           <a:srgbClr val="003399"/>
         </a:solidFill>
-        <a:effectLst/>
       </p:bgPr>
     </p:bg>
     <p:spTree>
@@ -9106,13 +8788,6 @@
             <a:prstDash val="solid"/>
           </a:ln>
         </p:spPr>
-        <p:txBody>
-          <a:bodyPr/>
-          <a:lstStyle/>
-          <a:p>
-            <a:endParaRPr lang="en-US"/>
-          </a:p>
-        </p:txBody>
       </p:sp>
       <p:sp>
         <p:nvSpPr>
@@ -9138,13 +8813,6 @@
             <a:prstDash val="solid"/>
           </a:ln>
         </p:spPr>
-        <p:txBody>
-          <a:bodyPr/>
-          <a:lstStyle/>
-          <a:p>
-            <a:endParaRPr lang="en-US"/>
-          </a:p>
-        </p:txBody>
       </p:sp>
       <p:sp>
         <p:nvSpPr>
@@ -9170,13 +8838,6 @@
             <a:prstDash val="solid"/>
           </a:ln>
         </p:spPr>
-        <p:txBody>
-          <a:bodyPr/>
-          <a:lstStyle/>
-          <a:p>
-            <a:endParaRPr lang="en-US"/>
-          </a:p>
-        </p:txBody>
       </p:sp>
       <p:sp>
         <p:nvSpPr>
@@ -9202,13 +8863,6 @@
             <a:prstDash val="solid"/>
           </a:ln>
         </p:spPr>
-        <p:txBody>
-          <a:bodyPr/>
-          <a:lstStyle/>
-          <a:p>
-            <a:endParaRPr lang="en-US"/>
-          </a:p>
-        </p:txBody>
       </p:sp>
       <p:sp>
         <p:nvSpPr>
@@ -9234,13 +8888,6 @@
             <a:prstDash val="solid"/>
           </a:ln>
         </p:spPr>
-        <p:txBody>
-          <a:bodyPr/>
-          <a:lstStyle/>
-          <a:p>
-            <a:endParaRPr lang="en-US"/>
-          </a:p>
-        </p:txBody>
       </p:sp>
       <p:sp>
         <p:nvSpPr>
@@ -9266,13 +8913,6 @@
             <a:prstDash val="solid"/>
           </a:ln>
         </p:spPr>
-        <p:txBody>
-          <a:bodyPr/>
-          <a:lstStyle/>
-          <a:p>
-            <a:endParaRPr lang="en-US"/>
-          </a:p>
-        </p:txBody>
       </p:sp>
       <p:sp>
         <p:nvSpPr>
@@ -9298,13 +8938,6 @@
             <a:prstDash val="solid"/>
           </a:ln>
         </p:spPr>
-        <p:txBody>
-          <a:bodyPr/>
-          <a:lstStyle/>
-          <a:p>
-            <a:endParaRPr lang="en-US"/>
-          </a:p>
-        </p:txBody>
       </p:sp>
       <p:sp>
         <p:nvSpPr>
@@ -9330,13 +8963,6 @@
             <a:prstDash val="solid"/>
           </a:ln>
         </p:spPr>
-        <p:txBody>
-          <a:bodyPr/>
-          <a:lstStyle/>
-          <a:p>
-            <a:endParaRPr lang="en-US"/>
-          </a:p>
-        </p:txBody>
       </p:sp>
       <p:sp>
         <p:nvSpPr>
@@ -9362,13 +8988,6 @@
             <a:prstDash val="solid"/>
           </a:ln>
         </p:spPr>
-        <p:txBody>
-          <a:bodyPr/>
-          <a:lstStyle/>
-          <a:p>
-            <a:endParaRPr lang="en-US"/>
-          </a:p>
-        </p:txBody>
       </p:sp>
       <p:sp>
         <p:nvSpPr>
@@ -9394,13 +9013,6 @@
             <a:prstDash val="solid"/>
           </a:ln>
         </p:spPr>
-        <p:txBody>
-          <a:bodyPr/>
-          <a:lstStyle/>
-          <a:p>
-            <a:endParaRPr lang="en-US"/>
-          </a:p>
-        </p:txBody>
       </p:sp>
       <p:sp>
         <p:nvSpPr>
@@ -9426,13 +9038,6 @@
             <a:prstDash val="solid"/>
           </a:ln>
         </p:spPr>
-        <p:txBody>
-          <a:bodyPr/>
-          <a:lstStyle/>
-          <a:p>
-            <a:endParaRPr lang="en-US"/>
-          </a:p>
-        </p:txBody>
       </p:sp>
       <p:sp>
         <p:nvSpPr>
@@ -9458,24 +9063,17 @@
             <a:prstDash val="solid"/>
           </a:ln>
         </p:spPr>
-        <p:txBody>
-          <a:bodyPr/>
-          <a:lstStyle/>
-          <a:p>
-            <a:endParaRPr lang="en-US"/>
-          </a:p>
-        </p:txBody>
       </p:sp>
       <p:pic>
         <p:nvPicPr>
-          <p:cNvPr id="14" name="Image 0" descr="preencoded.png"/>
+          <p:cNvPr id="14" name="Image 0" descr="preencoded.png">    </p:cNvPr>
           <p:cNvPicPr>
             <a:picLocks noChangeAspect="1"/>
           </p:cNvPicPr>
           <p:nvPr/>
         </p:nvPicPr>
         <p:blipFill>
-          <a:blip r:embed="rId3"/>
+          <a:blip r:embed="rId1"/>
           <a:stretch>
             <a:fillRect/>
           </a:stretch>
@@ -9511,11 +9109,11 @@
           <a:bodyPr wrap="square" lIns="0" tIns="0" rIns="0" bIns="0" rtlCol="0" anchor="ctr"/>
           <a:lstStyle/>
           <a:p>
-            <a:pPr marL="0" indent="0">
-              <a:buNone/>
-            </a:pPr>
-            <a:r>
-              <a:rPr lang="en-US" sz="1200" b="1" kern="0" spc="300" dirty="0">
+            <a:pPr indent="0" marL="0">
+              <a:buNone/>
+            </a:pPr>
+            <a:r>
+              <a:rPr lang="en-US" sz="1200" b="1" spc="300" kern="0" dirty="0">
                 <a:solidFill>
                   <a:srgbClr val="FFCC00"/>
                 </a:solidFill>
@@ -9550,7 +9148,7 @@
           <a:bodyPr wrap="square" lIns="0" tIns="0" rIns="0" bIns="0" rtlCol="0" anchor="ctr"/>
           <a:lstStyle/>
           <a:p>
-            <a:pPr marL="0" indent="0">
+            <a:pPr indent="0" marL="0">
               <a:lnSpc>
                 <a:spcPts val="4600"/>
               </a:lnSpc>
@@ -9570,7 +9168,7 @@
             <a:endParaRPr lang="en-US" sz="3800" dirty="0"/>
           </a:p>
           <a:p>
-            <a:pPr marL="0" indent="0">
+            <a:pPr indent="0" marL="0">
               <a:lnSpc>
                 <a:spcPts val="4600"/>
               </a:lnSpc>
@@ -9617,13 +9215,6 @@
             <a:prstDash val="solid"/>
           </a:ln>
         </p:spPr>
-        <p:txBody>
-          <a:bodyPr/>
-          <a:lstStyle/>
-          <a:p>
-            <a:endParaRPr lang="en-US"/>
-          </a:p>
-        </p:txBody>
       </p:sp>
       <p:sp>
         <p:nvSpPr>
@@ -9646,7 +9237,7 @@
           <a:bodyPr wrap="square" lIns="0" tIns="0" rIns="0" bIns="0" rtlCol="0" anchor="ctr"/>
           <a:lstStyle/>
           <a:p>
-            <a:pPr marL="0" indent="0">
+            <a:pPr indent="0" marL="0">
               <a:buNone/>
             </a:pPr>
             <a:r>
@@ -9685,7 +9276,7 @@
           <a:bodyPr wrap="square" lIns="0" tIns="0" rIns="0" bIns="0" rtlCol="0" anchor="ctr"/>
           <a:lstStyle/>
           <a:p>
-            <a:pPr marL="0" indent="0">
+            <a:pPr indent="0" marL="0">
               <a:lnSpc>
                 <a:spcPts val="1900"/>
               </a:lnSpc>
@@ -9732,13 +9323,6 @@
             <a:prstDash val="solid"/>
           </a:ln>
         </p:spPr>
-        <p:txBody>
-          <a:bodyPr/>
-          <a:lstStyle/>
-          <a:p>
-            <a:endParaRPr lang="en-US"/>
-          </a:p>
-        </p:txBody>
       </p:sp>
       <p:sp>
         <p:nvSpPr>
@@ -9761,7 +9345,7 @@
           <a:bodyPr wrap="square" lIns="0" tIns="0" rIns="0" bIns="0" rtlCol="0" anchor="ctr"/>
           <a:lstStyle/>
           <a:p>
-            <a:pPr marL="0" indent="0">
+            <a:pPr indent="0" marL="0">
               <a:buNone/>
             </a:pPr>
             <a:r>
@@ -9800,7 +9384,7 @@
           <a:bodyPr wrap="square" lIns="0" tIns="0" rIns="0" bIns="0" rtlCol="0" anchor="ctr"/>
           <a:lstStyle/>
           <a:p>
-            <a:pPr marL="0" indent="0">
+            <a:pPr indent="0" marL="0">
               <a:lnSpc>
                 <a:spcPts val="1900"/>
               </a:lnSpc>
@@ -9842,7 +9426,7 @@
           <a:bodyPr wrap="square" lIns="0" tIns="0" rIns="0" bIns="0" rtlCol="0" anchor="ctr"/>
           <a:lstStyle/>
           <a:p>
-            <a:pPr marL="0" indent="0">
+            <a:pPr indent="0" marL="0">
               <a:lnSpc>
                 <a:spcPts val="2200"/>
               </a:lnSpc>
@@ -10164,319 +9748,4 @@
     </a:ext>
   </a:extLst>
 </a:theme>
-</file>
-
-<file path=ppt/theme/theme2.xml><?xml version="1.0" encoding="utf-8"?>
-<a:theme xmlns:a="http://schemas.openxmlformats.org/drawingml/2006/main" name="Office Theme">
-  <a:themeElements>
-    <a:clrScheme name="Office">
-      <a:dk1>
-        <a:sysClr val="windowText" lastClr="000000"/>
-      </a:dk1>
-      <a:lt1>
-        <a:sysClr val="window" lastClr="FFFFFF"/>
-      </a:lt1>
-      <a:dk2>
-        <a:srgbClr val="0E2841"/>
-      </a:dk2>
-      <a:lt2>
-        <a:srgbClr val="E8E8E8"/>
-      </a:lt2>
-      <a:accent1>
-        <a:srgbClr val="156082"/>
-      </a:accent1>
-      <a:accent2>
-        <a:srgbClr val="E97132"/>
-      </a:accent2>
-      <a:accent3>
-        <a:srgbClr val="196B24"/>
-      </a:accent3>
-      <a:accent4>
-        <a:srgbClr val="0F9ED5"/>
-      </a:accent4>
-      <a:accent5>
-        <a:srgbClr val="A02B93"/>
-      </a:accent5>
-      <a:accent6>
-        <a:srgbClr val="4EA72E"/>
-      </a:accent6>
-      <a:hlink>
-        <a:srgbClr val="467886"/>
-      </a:hlink>
-      <a:folHlink>
-        <a:srgbClr val="96607D"/>
-      </a:folHlink>
-    </a:clrScheme>
-    <a:fontScheme name="Office">
-      <a:majorFont>
-        <a:latin typeface="Aptos Display" panose="02110004020202020204"/>
-        <a:ea typeface=""/>
-        <a:cs typeface=""/>
-        <a:font script="Jpan" typeface="游ゴシック Light"/>
-        <a:font script="Hang" typeface="맑은 고딕"/>
-        <a:font script="Hans" typeface="等线 Light"/>
-        <a:font script="Hant" typeface="新細明體"/>
-        <a:font script="Arab" typeface="Times New Roman"/>
-        <a:font script="Hebr" typeface="Times New Roman"/>
-        <a:font script="Thai" typeface="Angsana New"/>
-        <a:font script="Ethi" typeface="Nyala"/>
-        <a:font script="Beng" typeface="Vrinda"/>
-        <a:font script="Gujr" typeface="Shruti"/>
-        <a:font script="Khmr" typeface="MoolBoran"/>
-        <a:font script="Knda" typeface="Tunga"/>
-        <a:font script="Guru" typeface="Raavi"/>
-        <a:font script="Cans" typeface="Euphemia"/>
-        <a:font script="Cher" typeface="Plantagenet Cherokee"/>
-        <a:font script="Yiii" typeface="Microsoft Yi Baiti"/>
-        <a:font script="Tibt" typeface="Microsoft Himalaya"/>
-        <a:font script="Thaa" typeface="MV Boli"/>
-        <a:font script="Deva" typeface="Mangal"/>
-        <a:font script="Telu" typeface="Gautami"/>
-        <a:font script="Taml" typeface="Latha"/>
-        <a:font script="Syrc" typeface="Estrangelo Edessa"/>
-        <a:font script="Orya" typeface="Kalinga"/>
-        <a:font script="Mlym" typeface="Kartika"/>
-        <a:font script="Laoo" typeface="DokChampa"/>
-        <a:font script="Sinh" typeface="Iskoola Pota"/>
-        <a:font script="Mong" typeface="Mongolian Baiti"/>
-        <a:font script="Viet" typeface="Times New Roman"/>
-        <a:font script="Uigh" typeface="Microsoft Uighur"/>
-        <a:font script="Geor" typeface="Sylfaen"/>
-        <a:font script="Armn" typeface="Arial"/>
-        <a:font script="Bugi" typeface="Leelawadee UI"/>
-        <a:font script="Bopo" typeface="Microsoft JhengHei"/>
-        <a:font script="Java" typeface="Javanese Text"/>
-        <a:font script="Lisu" typeface="Segoe UI"/>
-        <a:font script="Mymr" typeface="Myanmar Text"/>
-        <a:font script="Nkoo" typeface="Ebrima"/>
-        <a:font script="Olck" typeface="Nirmala UI"/>
-        <a:font script="Osma" typeface="Ebrima"/>
-        <a:font script="Phag" typeface="Phagspa"/>
-        <a:font script="Syrn" typeface="Estrangelo Edessa"/>
-        <a:font script="Syrj" typeface="Estrangelo Edessa"/>
-        <a:font script="Syre" typeface="Estrangelo Edessa"/>
-        <a:font script="Sora" typeface="Nirmala UI"/>
-        <a:font script="Tale" typeface="Microsoft Tai Le"/>
-        <a:font script="Talu" typeface="Microsoft New Tai Lue"/>
-        <a:font script="Tfng" typeface="Ebrima"/>
-      </a:majorFont>
-      <a:minorFont>
-        <a:latin typeface="Aptos" panose="02110004020202020204"/>
-        <a:ea typeface=""/>
-        <a:cs typeface=""/>
-        <a:font script="Jpan" typeface="游ゴシック"/>
-        <a:font script="Hang" typeface="맑은 고딕"/>
-        <a:font script="Hans" typeface="等线"/>
-        <a:font script="Hant" typeface="新細明體"/>
-        <a:font script="Arab" typeface="Arial"/>
-        <a:font script="Hebr" typeface="Arial"/>
-        <a:font script="Thai" typeface="Cordia New"/>
-        <a:font script="Ethi" typeface="Nyala"/>
-        <a:font script="Beng" typeface="Vrinda"/>
-        <a:font script="Gujr" typeface="Shruti"/>
-        <a:font script="Khmr" typeface="DaunPenh"/>
-        <a:font script="Knda" typeface="Tunga"/>
-        <a:font script="Guru" typeface="Raavi"/>
-        <a:font script="Cans" typeface="Euphemia"/>
-        <a:font script="Cher" typeface="Plantagenet Cherokee"/>
-        <a:font script="Yiii" typeface="Microsoft Yi Baiti"/>
-        <a:font script="Tibt" typeface="Microsoft Himalaya"/>
-        <a:font script="Thaa" typeface="MV Boli"/>
-        <a:font script="Deva" typeface="Mangal"/>
-        <a:font script="Telu" typeface="Gautami"/>
-        <a:font script="Taml" typeface="Latha"/>
-        <a:font script="Syrc" typeface="Estrangelo Edessa"/>
-        <a:font script="Orya" typeface="Kalinga"/>
-        <a:font script="Mlym" typeface="Kartika"/>
-        <a:font script="Laoo" typeface="DokChampa"/>
-        <a:font script="Sinh" typeface="Iskoola Pota"/>
-        <a:font script="Mong" typeface="Mongolian Baiti"/>
-        <a:font script="Viet" typeface="Arial"/>
-        <a:font script="Uigh" typeface="Microsoft Uighur"/>
-        <a:font script="Geor" typeface="Sylfaen"/>
-        <a:font script="Armn" typeface="Arial"/>
-        <a:font script="Bugi" typeface="Leelawadee UI"/>
-        <a:font script="Bopo" typeface="Microsoft JhengHei"/>
-        <a:font script="Java" typeface="Javanese Text"/>
-        <a:font script="Lisu" typeface="Segoe UI"/>
-        <a:font script="Mymr" typeface="Myanmar Text"/>
-        <a:font script="Nkoo" typeface="Ebrima"/>
-        <a:font script="Olck" typeface="Nirmala UI"/>
-        <a:font script="Osma" typeface="Ebrima"/>
-        <a:font script="Phag" typeface="Phagspa"/>
-        <a:font script="Syrn" typeface="Estrangelo Edessa"/>
-        <a:font script="Syrj" typeface="Estrangelo Edessa"/>
-        <a:font script="Syre" typeface="Estrangelo Edessa"/>
-        <a:font script="Sora" typeface="Nirmala UI"/>
-        <a:font script="Tale" typeface="Microsoft Tai Le"/>
-        <a:font script="Talu" typeface="Microsoft New Tai Lue"/>
-        <a:font script="Tfng" typeface="Ebrima"/>
-      </a:minorFont>
-    </a:fontScheme>
-    <a:fmtScheme name="Office">
-      <a:fillStyleLst>
-        <a:solidFill>
-          <a:schemeClr val="phClr"/>
-        </a:solidFill>
-        <a:gradFill rotWithShape="1">
-          <a:gsLst>
-            <a:gs pos="0">
-              <a:schemeClr val="phClr">
-                <a:lumMod val="110000"/>
-                <a:satMod val="105000"/>
-                <a:tint val="67000"/>
-              </a:schemeClr>
-            </a:gs>
-            <a:gs pos="50000">
-              <a:schemeClr val="phClr">
-                <a:lumMod val="105000"/>
-                <a:satMod val="103000"/>
-                <a:tint val="73000"/>
-              </a:schemeClr>
-            </a:gs>
-            <a:gs pos="100000">
-              <a:schemeClr val="phClr">
-                <a:lumMod val="105000"/>
-                <a:satMod val="109000"/>
-                <a:tint val="81000"/>
-              </a:schemeClr>
-            </a:gs>
-          </a:gsLst>
-          <a:lin ang="5400000" scaled="0"/>
-        </a:gradFill>
-        <a:gradFill rotWithShape="1">
-          <a:gsLst>
-            <a:gs pos="0">
-              <a:schemeClr val="phClr">
-                <a:satMod val="103000"/>
-                <a:lumMod val="102000"/>
-                <a:tint val="94000"/>
-              </a:schemeClr>
-            </a:gs>
-            <a:gs pos="50000">
-              <a:schemeClr val="phClr">
-                <a:satMod val="110000"/>
-                <a:lumMod val="100000"/>
-                <a:shade val="100000"/>
-              </a:schemeClr>
-            </a:gs>
-            <a:gs pos="100000">
-              <a:schemeClr val="phClr">
-                <a:lumMod val="99000"/>
-                <a:satMod val="120000"/>
-                <a:shade val="78000"/>
-              </a:schemeClr>
-            </a:gs>
-          </a:gsLst>
-          <a:lin ang="5400000" scaled="0"/>
-        </a:gradFill>
-      </a:fillStyleLst>
-      <a:lnStyleLst>
-        <a:ln w="12700" cap="flat" cmpd="sng" algn="ctr">
-          <a:solidFill>
-            <a:schemeClr val="phClr"/>
-          </a:solidFill>
-          <a:prstDash val="solid"/>
-          <a:miter lim="800000"/>
-        </a:ln>
-        <a:ln w="19050" cap="flat" cmpd="sng" algn="ctr">
-          <a:solidFill>
-            <a:schemeClr val="phClr"/>
-          </a:solidFill>
-          <a:prstDash val="solid"/>
-          <a:miter lim="800000"/>
-        </a:ln>
-        <a:ln w="25400" cap="flat" cmpd="sng" algn="ctr">
-          <a:solidFill>
-            <a:schemeClr val="phClr"/>
-          </a:solidFill>
-          <a:prstDash val="solid"/>
-          <a:miter lim="800000"/>
-        </a:ln>
-      </a:lnStyleLst>
-      <a:effectStyleLst>
-        <a:effectStyle>
-          <a:effectLst/>
-        </a:effectStyle>
-        <a:effectStyle>
-          <a:effectLst/>
-        </a:effectStyle>
-        <a:effectStyle>
-          <a:effectLst>
-            <a:outerShdw blurRad="57150" dist="19050" dir="5400000" algn="ctr" rotWithShape="0">
-              <a:srgbClr val="000000">
-                <a:alpha val="63000"/>
-              </a:srgbClr>
-            </a:outerShdw>
-          </a:effectLst>
-        </a:effectStyle>
-      </a:effectStyleLst>
-      <a:bgFillStyleLst>
-        <a:solidFill>
-          <a:schemeClr val="phClr"/>
-        </a:solidFill>
-        <a:solidFill>
-          <a:schemeClr val="phClr">
-            <a:tint val="95000"/>
-            <a:satMod val="170000"/>
-          </a:schemeClr>
-        </a:solidFill>
-        <a:gradFill rotWithShape="1">
-          <a:gsLst>
-            <a:gs pos="0">
-              <a:schemeClr val="phClr">
-                <a:tint val="93000"/>
-                <a:satMod val="150000"/>
-                <a:shade val="98000"/>
-                <a:lumMod val="102000"/>
-              </a:schemeClr>
-            </a:gs>
-            <a:gs pos="50000">
-              <a:schemeClr val="phClr">
-                <a:tint val="98000"/>
-                <a:satMod val="130000"/>
-                <a:shade val="90000"/>
-                <a:lumMod val="103000"/>
-              </a:schemeClr>
-            </a:gs>
-            <a:gs pos="100000">
-              <a:schemeClr val="phClr">
-                <a:shade val="63000"/>
-                <a:satMod val="120000"/>
-              </a:schemeClr>
-            </a:gs>
-          </a:gsLst>
-          <a:lin ang="5400000" scaled="0"/>
-        </a:gradFill>
-      </a:bgFillStyleLst>
-    </a:fmtScheme>
-  </a:themeElements>
-  <a:objectDefaults>
-    <a:lnDef>
-      <a:spPr/>
-      <a:bodyPr/>
-      <a:lstStyle/>
-      <a:style>
-        <a:lnRef idx="2">
-          <a:schemeClr val="accent1"/>
-        </a:lnRef>
-        <a:fillRef idx="0">
-          <a:schemeClr val="accent1"/>
-        </a:fillRef>
-        <a:effectRef idx="1">
-          <a:schemeClr val="accent1"/>
-        </a:effectRef>
-        <a:fontRef idx="minor">
-          <a:schemeClr val="tx1"/>
-        </a:fontRef>
-      </a:style>
-    </a:lnDef>
-  </a:objectDefaults>
-  <a:extraClrSchemeLst/>
-  <a:extLst>
-    <a:ext uri="{05A4C25C-085E-4340-85A3-A5531E510DB2}">
-      <thm15:themeFamily xmlns:thm15="http://schemas.microsoft.com/office/thememl/2012/main" name="Office Theme" id="{2E142A2C-CD16-42D6-873A-C26D2A0506FA}" vid="{1BDDFF52-6CD6-40A5-AB3C-68EB2F1E4D0A}"/>
-    </a:ext>
-  </a:extLst>
-</a:theme>
 </file>
</xml_diff>